<commit_message>
Refine FDA data slide and update workflow
</commit_message>
<xml_diff>
--- a/downloads/fda-ai-enabled-medical-device-list-slide.pptx
+++ b/downloads/fda-ai-enabled-medical-device-list-slide.pptx
@@ -125,6 +125,1788 @@
               <c:strCache>
                 <c:ptCount val="1"/>
                 <c:pt idx="0">
+                  <c:v>Other</c:v>
+                </c:pt>
+              </c:strCache>
+            </c:strRef>
+          </c:tx>
+          <c:spPr>
+            <a:solidFill>
+              <a:srgbClr val="14725E"/>
+            </a:solidFill>
+            <a:ln>
+              <a:solidFill>
+                <a:srgbClr val="14725E"/>
+              </a:solidFill>
+            </a:ln>
+          </c:spPr>
+          <c:cat>
+            <c:strRef>
+              <c:f>Sheet1!$A$2:$A$27</c:f>
+              <c:strCache>
+                <c:ptCount val="26"/>
+                <c:pt idx="0">
+                  <c:v>1995</c:v>
+                </c:pt>
+                <c:pt idx="1">
+                  <c:v>1997</c:v>
+                </c:pt>
+                <c:pt idx="2">
+                  <c:v>1998</c:v>
+                </c:pt>
+                <c:pt idx="3">
+                  <c:v>2001</c:v>
+                </c:pt>
+                <c:pt idx="4">
+                  <c:v>2002</c:v>
+                </c:pt>
+                <c:pt idx="5">
+                  <c:v>2004</c:v>
+                </c:pt>
+                <c:pt idx="6">
+                  <c:v>2005</c:v>
+                </c:pt>
+                <c:pt idx="7">
+                  <c:v>2006</c:v>
+                </c:pt>
+                <c:pt idx="8">
+                  <c:v>2008</c:v>
+                </c:pt>
+                <c:pt idx="9">
+                  <c:v>2010</c:v>
+                </c:pt>
+                <c:pt idx="10">
+                  <c:v>2011</c:v>
+                </c:pt>
+                <c:pt idx="11">
+                  <c:v>2012</c:v>
+                </c:pt>
+                <c:pt idx="12">
+                  <c:v>2013</c:v>
+                </c:pt>
+                <c:pt idx="13">
+                  <c:v>2014</c:v>
+                </c:pt>
+                <c:pt idx="14">
+                  <c:v>2015</c:v>
+                </c:pt>
+                <c:pt idx="15">
+                  <c:v>2016</c:v>
+                </c:pt>
+                <c:pt idx="16">
+                  <c:v>2017</c:v>
+                </c:pt>
+                <c:pt idx="17">
+                  <c:v>2018</c:v>
+                </c:pt>
+                <c:pt idx="18">
+                  <c:v>2019</c:v>
+                </c:pt>
+                <c:pt idx="19">
+                  <c:v>2020</c:v>
+                </c:pt>
+                <c:pt idx="20">
+                  <c:v>2021</c:v>
+                </c:pt>
+                <c:pt idx="21">
+                  <c:v>2022</c:v>
+                </c:pt>
+                <c:pt idx="22">
+                  <c:v>2023</c:v>
+                </c:pt>
+                <c:pt idx="23">
+                  <c:v>2024</c:v>
+                </c:pt>
+                <c:pt idx="24">
+                  <c:v>2025</c:v>
+                </c:pt>
+                <c:pt idx="25">
+                  <c:v>2026</c:v>
+                </c:pt>
+              </c:strCache>
+            </c:strRef>
+          </c:cat>
+          <c:val>
+            <c:numRef>
+              <c:f>Sheet1!$B$2:$B$27</c:f>
+              <c:numCache>
+                <c:formatCode>General</c:formatCode>
+                <c:ptCount val="26"/>
+                <c:pt idx="0">
+                  <c:v>0</c:v>
+                </c:pt>
+                <c:pt idx="1">
+                  <c:v>0</c:v>
+                </c:pt>
+                <c:pt idx="2">
+                  <c:v>0</c:v>
+                </c:pt>
+                <c:pt idx="3">
+                  <c:v>0</c:v>
+                </c:pt>
+                <c:pt idx="4">
+                  <c:v>0</c:v>
+                </c:pt>
+                <c:pt idx="5">
+                  <c:v>0</c:v>
+                </c:pt>
+                <c:pt idx="6">
+                  <c:v>1</c:v>
+                </c:pt>
+                <c:pt idx="7">
+                  <c:v>1</c:v>
+                </c:pt>
+                <c:pt idx="8">
+                  <c:v>1</c:v>
+                </c:pt>
+                <c:pt idx="9">
+                  <c:v>1</c:v>
+                </c:pt>
+                <c:pt idx="10">
+                  <c:v>0</c:v>
+                </c:pt>
+                <c:pt idx="11">
+                  <c:v>1</c:v>
+                </c:pt>
+                <c:pt idx="12">
+                  <c:v>2</c:v>
+                </c:pt>
+                <c:pt idx="13">
+                  <c:v>0</c:v>
+                </c:pt>
+                <c:pt idx="14">
+                  <c:v>1</c:v>
+                </c:pt>
+                <c:pt idx="15">
+                  <c:v>2</c:v>
+                </c:pt>
+                <c:pt idx="16">
+                  <c:v>1</c:v>
+                </c:pt>
+                <c:pt idx="17">
+                  <c:v>5</c:v>
+                </c:pt>
+                <c:pt idx="18">
+                  <c:v>6</c:v>
+                </c:pt>
+                <c:pt idx="19">
+                  <c:v>1</c:v>
+                </c:pt>
+                <c:pt idx="20">
+                  <c:v>0</c:v>
+                </c:pt>
+                <c:pt idx="21">
+                  <c:v>1</c:v>
+                </c:pt>
+                <c:pt idx="22">
+                  <c:v>3</c:v>
+                </c:pt>
+                <c:pt idx="23">
+                  <c:v>6</c:v>
+                </c:pt>
+                <c:pt idx="24">
+                  <c:v>6</c:v>
+                </c:pt>
+                <c:pt idx="25">
+                  <c:v>10</c:v>
+                </c:pt>
+              </c:numCache>
+            </c:numRef>
+          </c:val>
+        </c:ser>
+        <c:ser>
+          <c:idx val="1"/>
+          <c:order val="1"/>
+          <c:tx>
+            <c:strRef>
+              <c:f>Sheet1!$C$1</c:f>
+              <c:strCache>
+                <c:ptCount val="1"/>
+                <c:pt idx="0">
+                  <c:v>General and Plastic Surgery</c:v>
+                </c:pt>
+              </c:strCache>
+            </c:strRef>
+          </c:tx>
+          <c:spPr>
+            <a:solidFill>
+              <a:srgbClr val="4B2CA3"/>
+            </a:solidFill>
+            <a:ln>
+              <a:solidFill>
+                <a:srgbClr val="4B2CA3"/>
+              </a:solidFill>
+            </a:ln>
+          </c:spPr>
+          <c:cat>
+            <c:strRef>
+              <c:f>Sheet1!$A$2:$A$27</c:f>
+              <c:strCache>
+                <c:ptCount val="26"/>
+                <c:pt idx="0">
+                  <c:v>1995</c:v>
+                </c:pt>
+                <c:pt idx="1">
+                  <c:v>1997</c:v>
+                </c:pt>
+                <c:pt idx="2">
+                  <c:v>1998</c:v>
+                </c:pt>
+                <c:pt idx="3">
+                  <c:v>2001</c:v>
+                </c:pt>
+                <c:pt idx="4">
+                  <c:v>2002</c:v>
+                </c:pt>
+                <c:pt idx="5">
+                  <c:v>2004</c:v>
+                </c:pt>
+                <c:pt idx="6">
+                  <c:v>2005</c:v>
+                </c:pt>
+                <c:pt idx="7">
+                  <c:v>2006</c:v>
+                </c:pt>
+                <c:pt idx="8">
+                  <c:v>2008</c:v>
+                </c:pt>
+                <c:pt idx="9">
+                  <c:v>2010</c:v>
+                </c:pt>
+                <c:pt idx="10">
+                  <c:v>2011</c:v>
+                </c:pt>
+                <c:pt idx="11">
+                  <c:v>2012</c:v>
+                </c:pt>
+                <c:pt idx="12">
+                  <c:v>2013</c:v>
+                </c:pt>
+                <c:pt idx="13">
+                  <c:v>2014</c:v>
+                </c:pt>
+                <c:pt idx="14">
+                  <c:v>2015</c:v>
+                </c:pt>
+                <c:pt idx="15">
+                  <c:v>2016</c:v>
+                </c:pt>
+                <c:pt idx="16">
+                  <c:v>2017</c:v>
+                </c:pt>
+                <c:pt idx="17">
+                  <c:v>2018</c:v>
+                </c:pt>
+                <c:pt idx="18">
+                  <c:v>2019</c:v>
+                </c:pt>
+                <c:pt idx="19">
+                  <c:v>2020</c:v>
+                </c:pt>
+                <c:pt idx="20">
+                  <c:v>2021</c:v>
+                </c:pt>
+                <c:pt idx="21">
+                  <c:v>2022</c:v>
+                </c:pt>
+                <c:pt idx="22">
+                  <c:v>2023</c:v>
+                </c:pt>
+                <c:pt idx="23">
+                  <c:v>2024</c:v>
+                </c:pt>
+                <c:pt idx="24">
+                  <c:v>2025</c:v>
+                </c:pt>
+                <c:pt idx="25">
+                  <c:v>2026</c:v>
+                </c:pt>
+              </c:strCache>
+            </c:strRef>
+          </c:cat>
+          <c:val>
+            <c:numRef>
+              <c:f>Sheet1!$C$2:$C$27</c:f>
+              <c:numCache>
+                <c:formatCode>General</c:formatCode>
+                <c:ptCount val="26"/>
+                <c:pt idx="0">
+                  <c:v>0</c:v>
+                </c:pt>
+                <c:pt idx="1">
+                  <c:v>0</c:v>
+                </c:pt>
+                <c:pt idx="2">
+                  <c:v>0</c:v>
+                </c:pt>
+                <c:pt idx="3">
+                  <c:v>0</c:v>
+                </c:pt>
+                <c:pt idx="4">
+                  <c:v>0</c:v>
+                </c:pt>
+                <c:pt idx="5">
+                  <c:v>0</c:v>
+                </c:pt>
+                <c:pt idx="6">
+                  <c:v>0</c:v>
+                </c:pt>
+                <c:pt idx="7">
+                  <c:v>0</c:v>
+                </c:pt>
+                <c:pt idx="8">
+                  <c:v>0</c:v>
+                </c:pt>
+                <c:pt idx="9">
+                  <c:v>0</c:v>
+                </c:pt>
+                <c:pt idx="10">
+                  <c:v>1</c:v>
+                </c:pt>
+                <c:pt idx="11">
+                  <c:v>1</c:v>
+                </c:pt>
+                <c:pt idx="12">
+                  <c:v>0</c:v>
+                </c:pt>
+                <c:pt idx="13">
+                  <c:v>0</c:v>
+                </c:pt>
+                <c:pt idx="14">
+                  <c:v>0</c:v>
+                </c:pt>
+                <c:pt idx="15">
+                  <c:v>0</c:v>
+                </c:pt>
+                <c:pt idx="16">
+                  <c:v>1</c:v>
+                </c:pt>
+                <c:pt idx="17">
+                  <c:v>0</c:v>
+                </c:pt>
+                <c:pt idx="18">
+                  <c:v>0</c:v>
+                </c:pt>
+                <c:pt idx="19">
+                  <c:v>0</c:v>
+                </c:pt>
+                <c:pt idx="20">
+                  <c:v>0</c:v>
+                </c:pt>
+                <c:pt idx="21">
+                  <c:v>0</c:v>
+                </c:pt>
+                <c:pt idx="22">
+                  <c:v>0</c:v>
+                </c:pt>
+                <c:pt idx="23">
+                  <c:v>2</c:v>
+                </c:pt>
+                <c:pt idx="24">
+                  <c:v>2</c:v>
+                </c:pt>
+                <c:pt idx="25">
+                  <c:v>2</c:v>
+                </c:pt>
+              </c:numCache>
+            </c:numRef>
+          </c:val>
+        </c:ser>
+        <c:ser>
+          <c:idx val="2"/>
+          <c:order val="2"/>
+          <c:tx>
+            <c:strRef>
+              <c:f>Sheet1!$D$1</c:f>
+              <c:strCache>
+                <c:ptCount val="1"/>
+                <c:pt idx="0">
+                  <c:v>Pathology</c:v>
+                </c:pt>
+              </c:strCache>
+            </c:strRef>
+          </c:tx>
+          <c:spPr>
+            <a:solidFill>
+              <a:srgbClr val="6A2CA0"/>
+            </a:solidFill>
+            <a:ln>
+              <a:solidFill>
+                <a:srgbClr val="6A2CA0"/>
+              </a:solidFill>
+            </a:ln>
+          </c:spPr>
+          <c:cat>
+            <c:strRef>
+              <c:f>Sheet1!$A$2:$A$27</c:f>
+              <c:strCache>
+                <c:ptCount val="26"/>
+                <c:pt idx="0">
+                  <c:v>1995</c:v>
+                </c:pt>
+                <c:pt idx="1">
+                  <c:v>1997</c:v>
+                </c:pt>
+                <c:pt idx="2">
+                  <c:v>1998</c:v>
+                </c:pt>
+                <c:pt idx="3">
+                  <c:v>2001</c:v>
+                </c:pt>
+                <c:pt idx="4">
+                  <c:v>2002</c:v>
+                </c:pt>
+                <c:pt idx="5">
+                  <c:v>2004</c:v>
+                </c:pt>
+                <c:pt idx="6">
+                  <c:v>2005</c:v>
+                </c:pt>
+                <c:pt idx="7">
+                  <c:v>2006</c:v>
+                </c:pt>
+                <c:pt idx="8">
+                  <c:v>2008</c:v>
+                </c:pt>
+                <c:pt idx="9">
+                  <c:v>2010</c:v>
+                </c:pt>
+                <c:pt idx="10">
+                  <c:v>2011</c:v>
+                </c:pt>
+                <c:pt idx="11">
+                  <c:v>2012</c:v>
+                </c:pt>
+                <c:pt idx="12">
+                  <c:v>2013</c:v>
+                </c:pt>
+                <c:pt idx="13">
+                  <c:v>2014</c:v>
+                </c:pt>
+                <c:pt idx="14">
+                  <c:v>2015</c:v>
+                </c:pt>
+                <c:pt idx="15">
+                  <c:v>2016</c:v>
+                </c:pt>
+                <c:pt idx="16">
+                  <c:v>2017</c:v>
+                </c:pt>
+                <c:pt idx="17">
+                  <c:v>2018</c:v>
+                </c:pt>
+                <c:pt idx="18">
+                  <c:v>2019</c:v>
+                </c:pt>
+                <c:pt idx="19">
+                  <c:v>2020</c:v>
+                </c:pt>
+                <c:pt idx="20">
+                  <c:v>2021</c:v>
+                </c:pt>
+                <c:pt idx="21">
+                  <c:v>2022</c:v>
+                </c:pt>
+                <c:pt idx="22">
+                  <c:v>2023</c:v>
+                </c:pt>
+                <c:pt idx="23">
+                  <c:v>2024</c:v>
+                </c:pt>
+                <c:pt idx="24">
+                  <c:v>2025</c:v>
+                </c:pt>
+                <c:pt idx="25">
+                  <c:v>2026</c:v>
+                </c:pt>
+              </c:strCache>
+            </c:strRef>
+          </c:cat>
+          <c:val>
+            <c:numRef>
+              <c:f>Sheet1!$D$2:$D$27</c:f>
+              <c:numCache>
+                <c:formatCode>General</c:formatCode>
+                <c:ptCount val="26"/>
+                <c:pt idx="0">
+                  <c:v>2</c:v>
+                </c:pt>
+                <c:pt idx="1">
+                  <c:v>0</c:v>
+                </c:pt>
+                <c:pt idx="2">
+                  <c:v>0</c:v>
+                </c:pt>
+                <c:pt idx="3">
+                  <c:v>0</c:v>
+                </c:pt>
+                <c:pt idx="4">
+                  <c:v>0</c:v>
+                </c:pt>
+                <c:pt idx="5">
+                  <c:v>0</c:v>
+                </c:pt>
+                <c:pt idx="6">
+                  <c:v>0</c:v>
+                </c:pt>
+                <c:pt idx="7">
+                  <c:v>0</c:v>
+                </c:pt>
+                <c:pt idx="8">
+                  <c:v>0</c:v>
+                </c:pt>
+                <c:pt idx="9">
+                  <c:v>0</c:v>
+                </c:pt>
+                <c:pt idx="10">
+                  <c:v>0</c:v>
+                </c:pt>
+                <c:pt idx="11">
+                  <c:v>0</c:v>
+                </c:pt>
+                <c:pt idx="12">
+                  <c:v>0</c:v>
+                </c:pt>
+                <c:pt idx="13">
+                  <c:v>0</c:v>
+                </c:pt>
+                <c:pt idx="14">
+                  <c:v>0</c:v>
+                </c:pt>
+                <c:pt idx="15">
+                  <c:v>0</c:v>
+                </c:pt>
+                <c:pt idx="16">
+                  <c:v>0</c:v>
+                </c:pt>
+                <c:pt idx="17">
+                  <c:v>0</c:v>
+                </c:pt>
+                <c:pt idx="18">
+                  <c:v>0</c:v>
+                </c:pt>
+                <c:pt idx="19">
+                  <c:v>0</c:v>
+                </c:pt>
+                <c:pt idx="20">
+                  <c:v>1</c:v>
+                </c:pt>
+                <c:pt idx="21">
+                  <c:v>0</c:v>
+                </c:pt>
+                <c:pt idx="22">
+                  <c:v>1</c:v>
+                </c:pt>
+                <c:pt idx="23">
+                  <c:v>1</c:v>
+                </c:pt>
+                <c:pt idx="24">
+                  <c:v>4</c:v>
+                </c:pt>
+                <c:pt idx="25">
+                  <c:v>1</c:v>
+                </c:pt>
+              </c:numCache>
+            </c:numRef>
+          </c:val>
+        </c:ser>
+        <c:ser>
+          <c:idx val="3"/>
+          <c:order val="3"/>
+          <c:tx>
+            <c:strRef>
+              <c:f>Sheet1!$E$1</c:f>
+              <c:strCache>
+                <c:ptCount val="1"/>
+                <c:pt idx="0">
+                  <c:v>Ophthalmic</c:v>
+                </c:pt>
+              </c:strCache>
+            </c:strRef>
+          </c:tx>
+          <c:spPr>
+            <a:solidFill>
+              <a:srgbClr val="3E8B45"/>
+            </a:solidFill>
+            <a:ln>
+              <a:solidFill>
+                <a:srgbClr val="3E8B45"/>
+              </a:solidFill>
+            </a:ln>
+          </c:spPr>
+          <c:cat>
+            <c:strRef>
+              <c:f>Sheet1!$A$2:$A$27</c:f>
+              <c:strCache>
+                <c:ptCount val="26"/>
+                <c:pt idx="0">
+                  <c:v>1995</c:v>
+                </c:pt>
+                <c:pt idx="1">
+                  <c:v>1997</c:v>
+                </c:pt>
+                <c:pt idx="2">
+                  <c:v>1998</c:v>
+                </c:pt>
+                <c:pt idx="3">
+                  <c:v>2001</c:v>
+                </c:pt>
+                <c:pt idx="4">
+                  <c:v>2002</c:v>
+                </c:pt>
+                <c:pt idx="5">
+                  <c:v>2004</c:v>
+                </c:pt>
+                <c:pt idx="6">
+                  <c:v>2005</c:v>
+                </c:pt>
+                <c:pt idx="7">
+                  <c:v>2006</c:v>
+                </c:pt>
+                <c:pt idx="8">
+                  <c:v>2008</c:v>
+                </c:pt>
+                <c:pt idx="9">
+                  <c:v>2010</c:v>
+                </c:pt>
+                <c:pt idx="10">
+                  <c:v>2011</c:v>
+                </c:pt>
+                <c:pt idx="11">
+                  <c:v>2012</c:v>
+                </c:pt>
+                <c:pt idx="12">
+                  <c:v>2013</c:v>
+                </c:pt>
+                <c:pt idx="13">
+                  <c:v>2014</c:v>
+                </c:pt>
+                <c:pt idx="14">
+                  <c:v>2015</c:v>
+                </c:pt>
+                <c:pt idx="15">
+                  <c:v>2016</c:v>
+                </c:pt>
+                <c:pt idx="16">
+                  <c:v>2017</c:v>
+                </c:pt>
+                <c:pt idx="17">
+                  <c:v>2018</c:v>
+                </c:pt>
+                <c:pt idx="18">
+                  <c:v>2019</c:v>
+                </c:pt>
+                <c:pt idx="19">
+                  <c:v>2020</c:v>
+                </c:pt>
+                <c:pt idx="20">
+                  <c:v>2021</c:v>
+                </c:pt>
+                <c:pt idx="21">
+                  <c:v>2022</c:v>
+                </c:pt>
+                <c:pt idx="22">
+                  <c:v>2023</c:v>
+                </c:pt>
+                <c:pt idx="23">
+                  <c:v>2024</c:v>
+                </c:pt>
+                <c:pt idx="24">
+                  <c:v>2025</c:v>
+                </c:pt>
+                <c:pt idx="25">
+                  <c:v>2026</c:v>
+                </c:pt>
+              </c:strCache>
+            </c:strRef>
+          </c:cat>
+          <c:val>
+            <c:numRef>
+              <c:f>Sheet1!$E$2:$E$27</c:f>
+              <c:numCache>
+                <c:formatCode>General</c:formatCode>
+                <c:ptCount val="26"/>
+                <c:pt idx="0">
+                  <c:v>0</c:v>
+                </c:pt>
+                <c:pt idx="1">
+                  <c:v>0</c:v>
+                </c:pt>
+                <c:pt idx="2">
+                  <c:v>0</c:v>
+                </c:pt>
+                <c:pt idx="3">
+                  <c:v>0</c:v>
+                </c:pt>
+                <c:pt idx="4">
+                  <c:v>0</c:v>
+                </c:pt>
+                <c:pt idx="5">
+                  <c:v>0</c:v>
+                </c:pt>
+                <c:pt idx="6">
+                  <c:v>0</c:v>
+                </c:pt>
+                <c:pt idx="7">
+                  <c:v>0</c:v>
+                </c:pt>
+                <c:pt idx="8">
+                  <c:v>0</c:v>
+                </c:pt>
+                <c:pt idx="9">
+                  <c:v>0</c:v>
+                </c:pt>
+                <c:pt idx="10">
+                  <c:v>0</c:v>
+                </c:pt>
+                <c:pt idx="11">
+                  <c:v>0</c:v>
+                </c:pt>
+                <c:pt idx="12">
+                  <c:v>0</c:v>
+                </c:pt>
+                <c:pt idx="13">
+                  <c:v>0</c:v>
+                </c:pt>
+                <c:pt idx="14">
+                  <c:v>0</c:v>
+                </c:pt>
+                <c:pt idx="15">
+                  <c:v>0</c:v>
+                </c:pt>
+                <c:pt idx="16">
+                  <c:v>0</c:v>
+                </c:pt>
+                <c:pt idx="17">
+                  <c:v>1</c:v>
+                </c:pt>
+                <c:pt idx="18">
+                  <c:v>1</c:v>
+                </c:pt>
+                <c:pt idx="19">
+                  <c:v>1</c:v>
+                </c:pt>
+                <c:pt idx="20">
+                  <c:v>1</c:v>
+                </c:pt>
+                <c:pt idx="21">
+                  <c:v>2</c:v>
+                </c:pt>
+                <c:pt idx="22">
+                  <c:v>1</c:v>
+                </c:pt>
+                <c:pt idx="23">
+                  <c:v>2</c:v>
+                </c:pt>
+                <c:pt idx="24">
+                  <c:v>1</c:v>
+                </c:pt>
+                <c:pt idx="25">
+                  <c:v>0</c:v>
+                </c:pt>
+              </c:numCache>
+            </c:numRef>
+          </c:val>
+        </c:ser>
+        <c:ser>
+          <c:idx val="4"/>
+          <c:order val="4"/>
+          <c:tx>
+            <c:strRef>
+              <c:f>Sheet1!$F$1</c:f>
+              <c:strCache>
+                <c:ptCount val="1"/>
+                <c:pt idx="0">
+                  <c:v>Hematology</c:v>
+                </c:pt>
+              </c:strCache>
+            </c:strRef>
+          </c:tx>
+          <c:spPr>
+            <a:solidFill>
+              <a:srgbClr val="F3A62A"/>
+            </a:solidFill>
+            <a:ln>
+              <a:solidFill>
+                <a:srgbClr val="F3A62A"/>
+              </a:solidFill>
+            </a:ln>
+          </c:spPr>
+          <c:cat>
+            <c:strRef>
+              <c:f>Sheet1!$A$2:$A$27</c:f>
+              <c:strCache>
+                <c:ptCount val="26"/>
+                <c:pt idx="0">
+                  <c:v>1995</c:v>
+                </c:pt>
+                <c:pt idx="1">
+                  <c:v>1997</c:v>
+                </c:pt>
+                <c:pt idx="2">
+                  <c:v>1998</c:v>
+                </c:pt>
+                <c:pt idx="3">
+                  <c:v>2001</c:v>
+                </c:pt>
+                <c:pt idx="4">
+                  <c:v>2002</c:v>
+                </c:pt>
+                <c:pt idx="5">
+                  <c:v>2004</c:v>
+                </c:pt>
+                <c:pt idx="6">
+                  <c:v>2005</c:v>
+                </c:pt>
+                <c:pt idx="7">
+                  <c:v>2006</c:v>
+                </c:pt>
+                <c:pt idx="8">
+                  <c:v>2008</c:v>
+                </c:pt>
+                <c:pt idx="9">
+                  <c:v>2010</c:v>
+                </c:pt>
+                <c:pt idx="10">
+                  <c:v>2011</c:v>
+                </c:pt>
+                <c:pt idx="11">
+                  <c:v>2012</c:v>
+                </c:pt>
+                <c:pt idx="12">
+                  <c:v>2013</c:v>
+                </c:pt>
+                <c:pt idx="13">
+                  <c:v>2014</c:v>
+                </c:pt>
+                <c:pt idx="14">
+                  <c:v>2015</c:v>
+                </c:pt>
+                <c:pt idx="15">
+                  <c:v>2016</c:v>
+                </c:pt>
+                <c:pt idx="16">
+                  <c:v>2017</c:v>
+                </c:pt>
+                <c:pt idx="17">
+                  <c:v>2018</c:v>
+                </c:pt>
+                <c:pt idx="18">
+                  <c:v>2019</c:v>
+                </c:pt>
+                <c:pt idx="19">
+                  <c:v>2020</c:v>
+                </c:pt>
+                <c:pt idx="20">
+                  <c:v>2021</c:v>
+                </c:pt>
+                <c:pt idx="21">
+                  <c:v>2022</c:v>
+                </c:pt>
+                <c:pt idx="22">
+                  <c:v>2023</c:v>
+                </c:pt>
+                <c:pt idx="23">
+                  <c:v>2024</c:v>
+                </c:pt>
+                <c:pt idx="24">
+                  <c:v>2025</c:v>
+                </c:pt>
+                <c:pt idx="25">
+                  <c:v>2026</c:v>
+                </c:pt>
+              </c:strCache>
+            </c:strRef>
+          </c:cat>
+          <c:val>
+            <c:numRef>
+              <c:f>Sheet1!$F$2:$F$27</c:f>
+              <c:numCache>
+                <c:formatCode>General</c:formatCode>
+                <c:ptCount val="26"/>
+                <c:pt idx="0">
+                  <c:v>0</c:v>
+                </c:pt>
+                <c:pt idx="1">
+                  <c:v>0</c:v>
+                </c:pt>
+                <c:pt idx="2">
+                  <c:v>0</c:v>
+                </c:pt>
+                <c:pt idx="3">
+                  <c:v>1</c:v>
+                </c:pt>
+                <c:pt idx="4">
+                  <c:v>0</c:v>
+                </c:pt>
+                <c:pt idx="5">
+                  <c:v>1</c:v>
+                </c:pt>
+                <c:pt idx="6">
+                  <c:v>0</c:v>
+                </c:pt>
+                <c:pt idx="7">
+                  <c:v>0</c:v>
+                </c:pt>
+                <c:pt idx="8">
+                  <c:v>1</c:v>
+                </c:pt>
+                <c:pt idx="9">
+                  <c:v>1</c:v>
+                </c:pt>
+                <c:pt idx="10">
+                  <c:v>1</c:v>
+                </c:pt>
+                <c:pt idx="11">
+                  <c:v>0</c:v>
+                </c:pt>
+                <c:pt idx="12">
+                  <c:v>1</c:v>
+                </c:pt>
+                <c:pt idx="13">
+                  <c:v>0</c:v>
+                </c:pt>
+                <c:pt idx="14">
+                  <c:v>0</c:v>
+                </c:pt>
+                <c:pt idx="15">
+                  <c:v>0</c:v>
+                </c:pt>
+                <c:pt idx="16">
+                  <c:v>1</c:v>
+                </c:pt>
+                <c:pt idx="17">
+                  <c:v>2</c:v>
+                </c:pt>
+                <c:pt idx="18">
+                  <c:v>1</c:v>
+                </c:pt>
+                <c:pt idx="19">
+                  <c:v>3</c:v>
+                </c:pt>
+                <c:pt idx="20">
+                  <c:v>0</c:v>
+                </c:pt>
+                <c:pt idx="21">
+                  <c:v>2</c:v>
+                </c:pt>
+                <c:pt idx="22">
+                  <c:v>1</c:v>
+                </c:pt>
+                <c:pt idx="23">
+                  <c:v>1</c:v>
+                </c:pt>
+                <c:pt idx="24">
+                  <c:v>3</c:v>
+                </c:pt>
+                <c:pt idx="25">
+                  <c:v>2</c:v>
+                </c:pt>
+              </c:numCache>
+            </c:numRef>
+          </c:val>
+        </c:ser>
+        <c:ser>
+          <c:idx val="5"/>
+          <c:order val="5"/>
+          <c:tx>
+            <c:strRef>
+              <c:f>Sheet1!$G$1</c:f>
+              <c:strCache>
+                <c:ptCount val="1"/>
+                <c:pt idx="0">
+                  <c:v>Gastroenterology-Urology</c:v>
+                </c:pt>
+              </c:strCache>
+            </c:strRef>
+          </c:tx>
+          <c:spPr>
+            <a:solidFill>
+              <a:srgbClr val="AD2458"/>
+            </a:solidFill>
+            <a:ln>
+              <a:solidFill>
+                <a:srgbClr val="AD2458"/>
+              </a:solidFill>
+            </a:ln>
+          </c:spPr>
+          <c:cat>
+            <c:strRef>
+              <c:f>Sheet1!$A$2:$A$27</c:f>
+              <c:strCache>
+                <c:ptCount val="26"/>
+                <c:pt idx="0">
+                  <c:v>1995</c:v>
+                </c:pt>
+                <c:pt idx="1">
+                  <c:v>1997</c:v>
+                </c:pt>
+                <c:pt idx="2">
+                  <c:v>1998</c:v>
+                </c:pt>
+                <c:pt idx="3">
+                  <c:v>2001</c:v>
+                </c:pt>
+                <c:pt idx="4">
+                  <c:v>2002</c:v>
+                </c:pt>
+                <c:pt idx="5">
+                  <c:v>2004</c:v>
+                </c:pt>
+                <c:pt idx="6">
+                  <c:v>2005</c:v>
+                </c:pt>
+                <c:pt idx="7">
+                  <c:v>2006</c:v>
+                </c:pt>
+                <c:pt idx="8">
+                  <c:v>2008</c:v>
+                </c:pt>
+                <c:pt idx="9">
+                  <c:v>2010</c:v>
+                </c:pt>
+                <c:pt idx="10">
+                  <c:v>2011</c:v>
+                </c:pt>
+                <c:pt idx="11">
+                  <c:v>2012</c:v>
+                </c:pt>
+                <c:pt idx="12">
+                  <c:v>2013</c:v>
+                </c:pt>
+                <c:pt idx="13">
+                  <c:v>2014</c:v>
+                </c:pt>
+                <c:pt idx="14">
+                  <c:v>2015</c:v>
+                </c:pt>
+                <c:pt idx="15">
+                  <c:v>2016</c:v>
+                </c:pt>
+                <c:pt idx="16">
+                  <c:v>2017</c:v>
+                </c:pt>
+                <c:pt idx="17">
+                  <c:v>2018</c:v>
+                </c:pt>
+                <c:pt idx="18">
+                  <c:v>2019</c:v>
+                </c:pt>
+                <c:pt idx="19">
+                  <c:v>2020</c:v>
+                </c:pt>
+                <c:pt idx="20">
+                  <c:v>2021</c:v>
+                </c:pt>
+                <c:pt idx="21">
+                  <c:v>2022</c:v>
+                </c:pt>
+                <c:pt idx="22">
+                  <c:v>2023</c:v>
+                </c:pt>
+                <c:pt idx="23">
+                  <c:v>2024</c:v>
+                </c:pt>
+                <c:pt idx="24">
+                  <c:v>2025</c:v>
+                </c:pt>
+                <c:pt idx="25">
+                  <c:v>2026</c:v>
+                </c:pt>
+              </c:strCache>
+            </c:strRef>
+          </c:cat>
+          <c:val>
+            <c:numRef>
+              <c:f>Sheet1!$G$2:$G$27</c:f>
+              <c:numCache>
+                <c:formatCode>General</c:formatCode>
+                <c:ptCount val="26"/>
+                <c:pt idx="0">
+                  <c:v>0</c:v>
+                </c:pt>
+                <c:pt idx="1">
+                  <c:v>0</c:v>
+                </c:pt>
+                <c:pt idx="2">
+                  <c:v>0</c:v>
+                </c:pt>
+                <c:pt idx="3">
+                  <c:v>0</c:v>
+                </c:pt>
+                <c:pt idx="4">
+                  <c:v>0</c:v>
+                </c:pt>
+                <c:pt idx="5">
+                  <c:v>0</c:v>
+                </c:pt>
+                <c:pt idx="6">
+                  <c:v>0</c:v>
+                </c:pt>
+                <c:pt idx="7">
+                  <c:v>0</c:v>
+                </c:pt>
+                <c:pt idx="8">
+                  <c:v>0</c:v>
+                </c:pt>
+                <c:pt idx="9">
+                  <c:v>0</c:v>
+                </c:pt>
+                <c:pt idx="10">
+                  <c:v>0</c:v>
+                </c:pt>
+                <c:pt idx="11">
+                  <c:v>0</c:v>
+                </c:pt>
+                <c:pt idx="12">
+                  <c:v>0</c:v>
+                </c:pt>
+                <c:pt idx="13">
+                  <c:v>0</c:v>
+                </c:pt>
+                <c:pt idx="14">
+                  <c:v>0</c:v>
+                </c:pt>
+                <c:pt idx="15">
+                  <c:v>0</c:v>
+                </c:pt>
+                <c:pt idx="16">
+                  <c:v>0</c:v>
+                </c:pt>
+                <c:pt idx="17">
+                  <c:v>1</c:v>
+                </c:pt>
+                <c:pt idx="18">
+                  <c:v>0</c:v>
+                </c:pt>
+                <c:pt idx="19">
+                  <c:v>0</c:v>
+                </c:pt>
+                <c:pt idx="20">
+                  <c:v>3</c:v>
+                </c:pt>
+                <c:pt idx="21">
+                  <c:v>1</c:v>
+                </c:pt>
+                <c:pt idx="22">
+                  <c:v>5</c:v>
+                </c:pt>
+                <c:pt idx="23">
+                  <c:v>5</c:v>
+                </c:pt>
+                <c:pt idx="24">
+                  <c:v>8</c:v>
+                </c:pt>
+                <c:pt idx="25">
+                  <c:v>4</c:v>
+                </c:pt>
+              </c:numCache>
+            </c:numRef>
+          </c:val>
+        </c:ser>
+        <c:ser>
+          <c:idx val="6"/>
+          <c:order val="6"/>
+          <c:tx>
+            <c:strRef>
+              <c:f>Sheet1!$H$1</c:f>
+              <c:strCache>
+                <c:ptCount val="1"/>
+                <c:pt idx="0">
+                  <c:v>Anesthesiology</c:v>
+                </c:pt>
+              </c:strCache>
+            </c:strRef>
+          </c:tx>
+          <c:spPr>
+            <a:solidFill>
+              <a:srgbClr val="16858C"/>
+            </a:solidFill>
+            <a:ln>
+              <a:solidFill>
+                <a:srgbClr val="16858C"/>
+              </a:solidFill>
+            </a:ln>
+          </c:spPr>
+          <c:cat>
+            <c:strRef>
+              <c:f>Sheet1!$A$2:$A$27</c:f>
+              <c:strCache>
+                <c:ptCount val="26"/>
+                <c:pt idx="0">
+                  <c:v>1995</c:v>
+                </c:pt>
+                <c:pt idx="1">
+                  <c:v>1997</c:v>
+                </c:pt>
+                <c:pt idx="2">
+                  <c:v>1998</c:v>
+                </c:pt>
+                <c:pt idx="3">
+                  <c:v>2001</c:v>
+                </c:pt>
+                <c:pt idx="4">
+                  <c:v>2002</c:v>
+                </c:pt>
+                <c:pt idx="5">
+                  <c:v>2004</c:v>
+                </c:pt>
+                <c:pt idx="6">
+                  <c:v>2005</c:v>
+                </c:pt>
+                <c:pt idx="7">
+                  <c:v>2006</c:v>
+                </c:pt>
+                <c:pt idx="8">
+                  <c:v>2008</c:v>
+                </c:pt>
+                <c:pt idx="9">
+                  <c:v>2010</c:v>
+                </c:pt>
+                <c:pt idx="10">
+                  <c:v>2011</c:v>
+                </c:pt>
+                <c:pt idx="11">
+                  <c:v>2012</c:v>
+                </c:pt>
+                <c:pt idx="12">
+                  <c:v>2013</c:v>
+                </c:pt>
+                <c:pt idx="13">
+                  <c:v>2014</c:v>
+                </c:pt>
+                <c:pt idx="14">
+                  <c:v>2015</c:v>
+                </c:pt>
+                <c:pt idx="15">
+                  <c:v>2016</c:v>
+                </c:pt>
+                <c:pt idx="16">
+                  <c:v>2017</c:v>
+                </c:pt>
+                <c:pt idx="17">
+                  <c:v>2018</c:v>
+                </c:pt>
+                <c:pt idx="18">
+                  <c:v>2019</c:v>
+                </c:pt>
+                <c:pt idx="19">
+                  <c:v>2020</c:v>
+                </c:pt>
+                <c:pt idx="20">
+                  <c:v>2021</c:v>
+                </c:pt>
+                <c:pt idx="21">
+                  <c:v>2022</c:v>
+                </c:pt>
+                <c:pt idx="22">
+                  <c:v>2023</c:v>
+                </c:pt>
+                <c:pt idx="23">
+                  <c:v>2024</c:v>
+                </c:pt>
+                <c:pt idx="24">
+                  <c:v>2025</c:v>
+                </c:pt>
+                <c:pt idx="25">
+                  <c:v>2026</c:v>
+                </c:pt>
+              </c:strCache>
+            </c:strRef>
+          </c:cat>
+          <c:val>
+            <c:numRef>
+              <c:f>Sheet1!$H$2:$H$27</c:f>
+              <c:numCache>
+                <c:formatCode>General</c:formatCode>
+                <c:ptCount val="26"/>
+                <c:pt idx="0">
+                  <c:v>0</c:v>
+                </c:pt>
+                <c:pt idx="1">
+                  <c:v>1</c:v>
+                </c:pt>
+                <c:pt idx="2">
+                  <c:v>0</c:v>
+                </c:pt>
+                <c:pt idx="3">
+                  <c:v>0</c:v>
+                </c:pt>
+                <c:pt idx="4">
+                  <c:v>0</c:v>
+                </c:pt>
+                <c:pt idx="5">
+                  <c:v>0</c:v>
+                </c:pt>
+                <c:pt idx="6">
+                  <c:v>0</c:v>
+                </c:pt>
+                <c:pt idx="7">
+                  <c:v>0</c:v>
+                </c:pt>
+                <c:pt idx="8">
+                  <c:v>0</c:v>
+                </c:pt>
+                <c:pt idx="9">
+                  <c:v>0</c:v>
+                </c:pt>
+                <c:pt idx="10">
+                  <c:v>0</c:v>
+                </c:pt>
+                <c:pt idx="11">
+                  <c:v>0</c:v>
+                </c:pt>
+                <c:pt idx="12">
+                  <c:v>0</c:v>
+                </c:pt>
+                <c:pt idx="13">
+                  <c:v>0</c:v>
+                </c:pt>
+                <c:pt idx="14">
+                  <c:v>2</c:v>
+                </c:pt>
+                <c:pt idx="15">
+                  <c:v>0</c:v>
+                </c:pt>
+                <c:pt idx="16">
+                  <c:v>1</c:v>
+                </c:pt>
+                <c:pt idx="17">
+                  <c:v>0</c:v>
+                </c:pt>
+                <c:pt idx="18">
+                  <c:v>1</c:v>
+                </c:pt>
+                <c:pt idx="19">
+                  <c:v>1</c:v>
+                </c:pt>
+                <c:pt idx="20">
+                  <c:v>0</c:v>
+                </c:pt>
+                <c:pt idx="21">
+                  <c:v>2</c:v>
+                </c:pt>
+                <c:pt idx="22">
+                  <c:v>5</c:v>
+                </c:pt>
+                <c:pt idx="23">
+                  <c:v>5</c:v>
+                </c:pt>
+                <c:pt idx="24">
+                  <c:v>8</c:v>
+                </c:pt>
+                <c:pt idx="25">
+                  <c:v>4</c:v>
+                </c:pt>
+              </c:numCache>
+            </c:numRef>
+          </c:val>
+        </c:ser>
+        <c:ser>
+          <c:idx val="7"/>
+          <c:order val="7"/>
+          <c:tx>
+            <c:strRef>
+              <c:f>Sheet1!$I$1</c:f>
+              <c:strCache>
+                <c:ptCount val="1"/>
+                <c:pt idx="0">
+                  <c:v>Neurology</c:v>
+                </c:pt>
+              </c:strCache>
+            </c:strRef>
+          </c:tx>
+          <c:spPr>
+            <a:solidFill>
+              <a:srgbClr val="E97817"/>
+            </a:solidFill>
+            <a:ln>
+              <a:solidFill>
+                <a:srgbClr val="E97817"/>
+              </a:solidFill>
+            </a:ln>
+          </c:spPr>
+          <c:cat>
+            <c:strRef>
+              <c:f>Sheet1!$A$2:$A$27</c:f>
+              <c:strCache>
+                <c:ptCount val="26"/>
+                <c:pt idx="0">
+                  <c:v>1995</c:v>
+                </c:pt>
+                <c:pt idx="1">
+                  <c:v>1997</c:v>
+                </c:pt>
+                <c:pt idx="2">
+                  <c:v>1998</c:v>
+                </c:pt>
+                <c:pt idx="3">
+                  <c:v>2001</c:v>
+                </c:pt>
+                <c:pt idx="4">
+                  <c:v>2002</c:v>
+                </c:pt>
+                <c:pt idx="5">
+                  <c:v>2004</c:v>
+                </c:pt>
+                <c:pt idx="6">
+                  <c:v>2005</c:v>
+                </c:pt>
+                <c:pt idx="7">
+                  <c:v>2006</c:v>
+                </c:pt>
+                <c:pt idx="8">
+                  <c:v>2008</c:v>
+                </c:pt>
+                <c:pt idx="9">
+                  <c:v>2010</c:v>
+                </c:pt>
+                <c:pt idx="10">
+                  <c:v>2011</c:v>
+                </c:pt>
+                <c:pt idx="11">
+                  <c:v>2012</c:v>
+                </c:pt>
+                <c:pt idx="12">
+                  <c:v>2013</c:v>
+                </c:pt>
+                <c:pt idx="13">
+                  <c:v>2014</c:v>
+                </c:pt>
+                <c:pt idx="14">
+                  <c:v>2015</c:v>
+                </c:pt>
+                <c:pt idx="15">
+                  <c:v>2016</c:v>
+                </c:pt>
+                <c:pt idx="16">
+                  <c:v>2017</c:v>
+                </c:pt>
+                <c:pt idx="17">
+                  <c:v>2018</c:v>
+                </c:pt>
+                <c:pt idx="18">
+                  <c:v>2019</c:v>
+                </c:pt>
+                <c:pt idx="19">
+                  <c:v>2020</c:v>
+                </c:pt>
+                <c:pt idx="20">
+                  <c:v>2021</c:v>
+                </c:pt>
+                <c:pt idx="21">
+                  <c:v>2022</c:v>
+                </c:pt>
+                <c:pt idx="22">
+                  <c:v>2023</c:v>
+                </c:pt>
+                <c:pt idx="23">
+                  <c:v>2024</c:v>
+                </c:pt>
+                <c:pt idx="24">
+                  <c:v>2025</c:v>
+                </c:pt>
+                <c:pt idx="25">
+                  <c:v>2026</c:v>
+                </c:pt>
+              </c:strCache>
+            </c:strRef>
+          </c:cat>
+          <c:val>
+            <c:numRef>
+              <c:f>Sheet1!$I$2:$I$27</c:f>
+              <c:numCache>
+                <c:formatCode>General</c:formatCode>
+                <c:ptCount val="26"/>
+                <c:pt idx="0">
+                  <c:v>0</c:v>
+                </c:pt>
+                <c:pt idx="1">
+                  <c:v>0</c:v>
+                </c:pt>
+                <c:pt idx="2">
+                  <c:v>0</c:v>
+                </c:pt>
+                <c:pt idx="3">
+                  <c:v>0</c:v>
+                </c:pt>
+                <c:pt idx="4">
+                  <c:v>0</c:v>
+                </c:pt>
+                <c:pt idx="5">
+                  <c:v>0</c:v>
+                </c:pt>
+                <c:pt idx="6">
+                  <c:v>0</c:v>
+                </c:pt>
+                <c:pt idx="7">
+                  <c:v>0</c:v>
+                </c:pt>
+                <c:pt idx="8">
+                  <c:v>0</c:v>
+                </c:pt>
+                <c:pt idx="9">
+                  <c:v>0</c:v>
+                </c:pt>
+                <c:pt idx="10">
+                  <c:v>0</c:v>
+                </c:pt>
+                <c:pt idx="11">
+                  <c:v>0</c:v>
+                </c:pt>
+                <c:pt idx="12">
+                  <c:v>0</c:v>
+                </c:pt>
+                <c:pt idx="13">
+                  <c:v>1</c:v>
+                </c:pt>
+                <c:pt idx="14">
+                  <c:v>1</c:v>
+                </c:pt>
+                <c:pt idx="15">
+                  <c:v>1</c:v>
+                </c:pt>
+                <c:pt idx="16">
+                  <c:v>0</c:v>
+                </c:pt>
+                <c:pt idx="17">
+                  <c:v>6</c:v>
+                </c:pt>
+                <c:pt idx="18">
+                  <c:v>5</c:v>
+                </c:pt>
+                <c:pt idx="19">
+                  <c:v>1</c:v>
+                </c:pt>
+                <c:pt idx="20">
+                  <c:v>3</c:v>
+                </c:pt>
+                <c:pt idx="21">
+                  <c:v>2</c:v>
+                </c:pt>
+                <c:pt idx="22">
+                  <c:v>11</c:v>
+                </c:pt>
+                <c:pt idx="23">
+                  <c:v>15</c:v>
+                </c:pt>
+                <c:pt idx="24">
+                  <c:v>19</c:v>
+                </c:pt>
+                <c:pt idx="25">
+                  <c:v>8</c:v>
+                </c:pt>
+              </c:numCache>
+            </c:numRef>
+          </c:val>
+        </c:ser>
+        <c:ser>
+          <c:idx val="8"/>
+          <c:order val="8"/>
+          <c:tx>
+            <c:strRef>
+              <c:f>Sheet1!$J$1</c:f>
+              <c:strCache>
+                <c:ptCount val="1"/>
+                <c:pt idx="0">
+                  <c:v>Cardiovascular</c:v>
+                </c:pt>
+              </c:strCache>
+            </c:strRef>
+          </c:tx>
+          <c:spPr>
+            <a:solidFill>
+              <a:srgbClr val="C93636"/>
+            </a:solidFill>
+            <a:ln>
+              <a:solidFill>
+                <a:srgbClr val="C93636"/>
+              </a:solidFill>
+            </a:ln>
+          </c:spPr>
+          <c:cat>
+            <c:strRef>
+              <c:f>Sheet1!$A$2:$A$27</c:f>
+              <c:strCache>
+                <c:ptCount val="26"/>
+                <c:pt idx="0">
+                  <c:v>1995</c:v>
+                </c:pt>
+                <c:pt idx="1">
+                  <c:v>1997</c:v>
+                </c:pt>
+                <c:pt idx="2">
+                  <c:v>1998</c:v>
+                </c:pt>
+                <c:pt idx="3">
+                  <c:v>2001</c:v>
+                </c:pt>
+                <c:pt idx="4">
+                  <c:v>2002</c:v>
+                </c:pt>
+                <c:pt idx="5">
+                  <c:v>2004</c:v>
+                </c:pt>
+                <c:pt idx="6">
+                  <c:v>2005</c:v>
+                </c:pt>
+                <c:pt idx="7">
+                  <c:v>2006</c:v>
+                </c:pt>
+                <c:pt idx="8">
+                  <c:v>2008</c:v>
+                </c:pt>
+                <c:pt idx="9">
+                  <c:v>2010</c:v>
+                </c:pt>
+                <c:pt idx="10">
+                  <c:v>2011</c:v>
+                </c:pt>
+                <c:pt idx="11">
+                  <c:v>2012</c:v>
+                </c:pt>
+                <c:pt idx="12">
+                  <c:v>2013</c:v>
+                </c:pt>
+                <c:pt idx="13">
+                  <c:v>2014</c:v>
+                </c:pt>
+                <c:pt idx="14">
+                  <c:v>2015</c:v>
+                </c:pt>
+                <c:pt idx="15">
+                  <c:v>2016</c:v>
+                </c:pt>
+                <c:pt idx="16">
+                  <c:v>2017</c:v>
+                </c:pt>
+                <c:pt idx="17">
+                  <c:v>2018</c:v>
+                </c:pt>
+                <c:pt idx="18">
+                  <c:v>2019</c:v>
+                </c:pt>
+                <c:pt idx="19">
+                  <c:v>2020</c:v>
+                </c:pt>
+                <c:pt idx="20">
+                  <c:v>2021</c:v>
+                </c:pt>
+                <c:pt idx="21">
+                  <c:v>2022</c:v>
+                </c:pt>
+                <c:pt idx="22">
+                  <c:v>2023</c:v>
+                </c:pt>
+                <c:pt idx="23">
+                  <c:v>2024</c:v>
+                </c:pt>
+                <c:pt idx="24">
+                  <c:v>2025</c:v>
+                </c:pt>
+                <c:pt idx="25">
+                  <c:v>2026</c:v>
+                </c:pt>
+              </c:strCache>
+            </c:strRef>
+          </c:cat>
+          <c:val>
+            <c:numRef>
+              <c:f>Sheet1!$J$2:$J$27</c:f>
+              <c:numCache>
+                <c:formatCode>General</c:formatCode>
+                <c:ptCount val="26"/>
+                <c:pt idx="0">
+                  <c:v>0</c:v>
+                </c:pt>
+                <c:pt idx="1">
+                  <c:v>0</c:v>
+                </c:pt>
+                <c:pt idx="2">
+                  <c:v>0</c:v>
+                </c:pt>
+                <c:pt idx="3">
+                  <c:v>0</c:v>
+                </c:pt>
+                <c:pt idx="4">
+                  <c:v>0</c:v>
+                </c:pt>
+                <c:pt idx="5">
+                  <c:v>0</c:v>
+                </c:pt>
+                <c:pt idx="6">
+                  <c:v>0</c:v>
+                </c:pt>
+                <c:pt idx="7">
+                  <c:v>0</c:v>
+                </c:pt>
+                <c:pt idx="8">
+                  <c:v>1</c:v>
+                </c:pt>
+                <c:pt idx="9">
+                  <c:v>0</c:v>
+                </c:pt>
+                <c:pt idx="10">
+                  <c:v>0</c:v>
+                </c:pt>
+                <c:pt idx="11">
+                  <c:v>1</c:v>
+                </c:pt>
+                <c:pt idx="12">
+                  <c:v>1</c:v>
+                </c:pt>
+                <c:pt idx="13">
+                  <c:v>0</c:v>
+                </c:pt>
+                <c:pt idx="14">
+                  <c:v>1</c:v>
+                </c:pt>
+                <c:pt idx="15">
+                  <c:v>4</c:v>
+                </c:pt>
+                <c:pt idx="16">
+                  <c:v>7</c:v>
+                </c:pt>
+                <c:pt idx="17">
+                  <c:v>10</c:v>
+                </c:pt>
+                <c:pt idx="18">
+                  <c:v>15</c:v>
+                </c:pt>
+                <c:pt idx="19">
+                  <c:v>8</c:v>
+                </c:pt>
+                <c:pt idx="20">
+                  <c:v>11</c:v>
+                </c:pt>
+                <c:pt idx="21">
+                  <c:v>14</c:v>
+                </c:pt>
+                <c:pt idx="22">
+                  <c:v>21</c:v>
+                </c:pt>
+                <c:pt idx="23">
+                  <c:v>15</c:v>
+                </c:pt>
+                <c:pt idx="24">
+                  <c:v>30</c:v>
+                </c:pt>
+                <c:pt idx="25">
+                  <c:v>15</c:v>
+                </c:pt>
+              </c:numCache>
+            </c:numRef>
+          </c:val>
+        </c:ser>
+        <c:ser>
+          <c:idx val="9"/>
+          <c:order val="9"/>
+          <c:tx>
+            <c:strRef>
+              <c:f>Sheet1!$K$1</c:f>
+              <c:strCache>
+                <c:ptCount val="1"/>
+                <c:pt idx="0">
                   <c:v>Radiology</c:v>
                 </c:pt>
               </c:strCache>
@@ -228,1788 +2010,6 @@
           </c:cat>
           <c:val>
             <c:numRef>
-              <c:f>Sheet1!$B$2:$B$27</c:f>
-              <c:numCache>
-                <c:formatCode>General</c:formatCode>
-                <c:ptCount val="26"/>
-                <c:pt idx="0">
-                  <c:v>0</c:v>
-                </c:pt>
-                <c:pt idx="1">
-                  <c:v>0</c:v>
-                </c:pt>
-                <c:pt idx="2">
-                  <c:v>2</c:v>
-                </c:pt>
-                <c:pt idx="3">
-                  <c:v>1</c:v>
-                </c:pt>
-                <c:pt idx="4">
-                  <c:v>1</c:v>
-                </c:pt>
-                <c:pt idx="5">
-                  <c:v>0</c:v>
-                </c:pt>
-                <c:pt idx="6">
-                  <c:v>0</c:v>
-                </c:pt>
-                <c:pt idx="7">
-                  <c:v>0</c:v>
-                </c:pt>
-                <c:pt idx="8">
-                  <c:v>2</c:v>
-                </c:pt>
-                <c:pt idx="9">
-                  <c:v>0</c:v>
-                </c:pt>
-                <c:pt idx="10">
-                  <c:v>1</c:v>
-                </c:pt>
-                <c:pt idx="11">
-                  <c:v>2</c:v>
-                </c:pt>
-                <c:pt idx="12">
-                  <c:v>0</c:v>
-                </c:pt>
-                <c:pt idx="13">
-                  <c:v>5</c:v>
-                </c:pt>
-                <c:pt idx="14">
-                  <c:v>1</c:v>
-                </c:pt>
-                <c:pt idx="15">
-                  <c:v>11</c:v>
-                </c:pt>
-                <c:pt idx="16">
-                  <c:v>16</c:v>
-                </c:pt>
-                <c:pt idx="17">
-                  <c:v>40</c:v>
-                </c:pt>
-                <c:pt idx="18">
-                  <c:v>51</c:v>
-                </c:pt>
-                <c:pt idx="19">
-                  <c:v>99</c:v>
-                </c:pt>
-                <c:pt idx="20">
-                  <c:v>110</c:v>
-                </c:pt>
-                <c:pt idx="21">
-                  <c:v>138</c:v>
-                </c:pt>
-                <c:pt idx="22">
-                  <c:v>178</c:v>
-                </c:pt>
-                <c:pt idx="23">
-                  <c:v>183</c:v>
-                </c:pt>
-                <c:pt idx="24">
-                  <c:v>254</c:v>
-                </c:pt>
-                <c:pt idx="25">
-                  <c:v>135</c:v>
-                </c:pt>
-              </c:numCache>
-            </c:numRef>
-          </c:val>
-        </c:ser>
-        <c:ser>
-          <c:idx val="1"/>
-          <c:order val="1"/>
-          <c:tx>
-            <c:strRef>
-              <c:f>Sheet1!$C$1</c:f>
-              <c:strCache>
-                <c:ptCount val="1"/>
-                <c:pt idx="0">
-                  <c:v>Cardiovascular</c:v>
-                </c:pt>
-              </c:strCache>
-            </c:strRef>
-          </c:tx>
-          <c:spPr>
-            <a:solidFill>
-              <a:srgbClr val="C93636"/>
-            </a:solidFill>
-            <a:ln>
-              <a:solidFill>
-                <a:srgbClr val="C93636"/>
-              </a:solidFill>
-            </a:ln>
-          </c:spPr>
-          <c:cat>
-            <c:strRef>
-              <c:f>Sheet1!$A$2:$A$27</c:f>
-              <c:strCache>
-                <c:ptCount val="26"/>
-                <c:pt idx="0">
-                  <c:v>1995</c:v>
-                </c:pt>
-                <c:pt idx="1">
-                  <c:v>1997</c:v>
-                </c:pt>
-                <c:pt idx="2">
-                  <c:v>1998</c:v>
-                </c:pt>
-                <c:pt idx="3">
-                  <c:v>2001</c:v>
-                </c:pt>
-                <c:pt idx="4">
-                  <c:v>2002</c:v>
-                </c:pt>
-                <c:pt idx="5">
-                  <c:v>2004</c:v>
-                </c:pt>
-                <c:pt idx="6">
-                  <c:v>2005</c:v>
-                </c:pt>
-                <c:pt idx="7">
-                  <c:v>2006</c:v>
-                </c:pt>
-                <c:pt idx="8">
-                  <c:v>2008</c:v>
-                </c:pt>
-                <c:pt idx="9">
-                  <c:v>2010</c:v>
-                </c:pt>
-                <c:pt idx="10">
-                  <c:v>2011</c:v>
-                </c:pt>
-                <c:pt idx="11">
-                  <c:v>2012</c:v>
-                </c:pt>
-                <c:pt idx="12">
-                  <c:v>2013</c:v>
-                </c:pt>
-                <c:pt idx="13">
-                  <c:v>2014</c:v>
-                </c:pt>
-                <c:pt idx="14">
-                  <c:v>2015</c:v>
-                </c:pt>
-                <c:pt idx="15">
-                  <c:v>2016</c:v>
-                </c:pt>
-                <c:pt idx="16">
-                  <c:v>2017</c:v>
-                </c:pt>
-                <c:pt idx="17">
-                  <c:v>2018</c:v>
-                </c:pt>
-                <c:pt idx="18">
-                  <c:v>2019</c:v>
-                </c:pt>
-                <c:pt idx="19">
-                  <c:v>2020</c:v>
-                </c:pt>
-                <c:pt idx="20">
-                  <c:v>2021</c:v>
-                </c:pt>
-                <c:pt idx="21">
-                  <c:v>2022</c:v>
-                </c:pt>
-                <c:pt idx="22">
-                  <c:v>2023</c:v>
-                </c:pt>
-                <c:pt idx="23">
-                  <c:v>2024</c:v>
-                </c:pt>
-                <c:pt idx="24">
-                  <c:v>2025</c:v>
-                </c:pt>
-                <c:pt idx="25">
-                  <c:v>2026</c:v>
-                </c:pt>
-              </c:strCache>
-            </c:strRef>
-          </c:cat>
-          <c:val>
-            <c:numRef>
-              <c:f>Sheet1!$C$2:$C$27</c:f>
-              <c:numCache>
-                <c:formatCode>General</c:formatCode>
-                <c:ptCount val="26"/>
-                <c:pt idx="0">
-                  <c:v>0</c:v>
-                </c:pt>
-                <c:pt idx="1">
-                  <c:v>0</c:v>
-                </c:pt>
-                <c:pt idx="2">
-                  <c:v>0</c:v>
-                </c:pt>
-                <c:pt idx="3">
-                  <c:v>0</c:v>
-                </c:pt>
-                <c:pt idx="4">
-                  <c:v>0</c:v>
-                </c:pt>
-                <c:pt idx="5">
-                  <c:v>0</c:v>
-                </c:pt>
-                <c:pt idx="6">
-                  <c:v>0</c:v>
-                </c:pt>
-                <c:pt idx="7">
-                  <c:v>0</c:v>
-                </c:pt>
-                <c:pt idx="8">
-                  <c:v>1</c:v>
-                </c:pt>
-                <c:pt idx="9">
-                  <c:v>0</c:v>
-                </c:pt>
-                <c:pt idx="10">
-                  <c:v>0</c:v>
-                </c:pt>
-                <c:pt idx="11">
-                  <c:v>1</c:v>
-                </c:pt>
-                <c:pt idx="12">
-                  <c:v>1</c:v>
-                </c:pt>
-                <c:pt idx="13">
-                  <c:v>0</c:v>
-                </c:pt>
-                <c:pt idx="14">
-                  <c:v>1</c:v>
-                </c:pt>
-                <c:pt idx="15">
-                  <c:v>4</c:v>
-                </c:pt>
-                <c:pt idx="16">
-                  <c:v>7</c:v>
-                </c:pt>
-                <c:pt idx="17">
-                  <c:v>10</c:v>
-                </c:pt>
-                <c:pt idx="18">
-                  <c:v>15</c:v>
-                </c:pt>
-                <c:pt idx="19">
-                  <c:v>8</c:v>
-                </c:pt>
-                <c:pt idx="20">
-                  <c:v>11</c:v>
-                </c:pt>
-                <c:pt idx="21">
-                  <c:v>14</c:v>
-                </c:pt>
-                <c:pt idx="22">
-                  <c:v>21</c:v>
-                </c:pt>
-                <c:pt idx="23">
-                  <c:v>15</c:v>
-                </c:pt>
-                <c:pt idx="24">
-                  <c:v>30</c:v>
-                </c:pt>
-                <c:pt idx="25">
-                  <c:v>15</c:v>
-                </c:pt>
-              </c:numCache>
-            </c:numRef>
-          </c:val>
-        </c:ser>
-        <c:ser>
-          <c:idx val="2"/>
-          <c:order val="2"/>
-          <c:tx>
-            <c:strRef>
-              <c:f>Sheet1!$D$1</c:f>
-              <c:strCache>
-                <c:ptCount val="1"/>
-                <c:pt idx="0">
-                  <c:v>Neurology</c:v>
-                </c:pt>
-              </c:strCache>
-            </c:strRef>
-          </c:tx>
-          <c:spPr>
-            <a:solidFill>
-              <a:srgbClr val="E97817"/>
-            </a:solidFill>
-            <a:ln>
-              <a:solidFill>
-                <a:srgbClr val="E97817"/>
-              </a:solidFill>
-            </a:ln>
-          </c:spPr>
-          <c:cat>
-            <c:strRef>
-              <c:f>Sheet1!$A$2:$A$27</c:f>
-              <c:strCache>
-                <c:ptCount val="26"/>
-                <c:pt idx="0">
-                  <c:v>1995</c:v>
-                </c:pt>
-                <c:pt idx="1">
-                  <c:v>1997</c:v>
-                </c:pt>
-                <c:pt idx="2">
-                  <c:v>1998</c:v>
-                </c:pt>
-                <c:pt idx="3">
-                  <c:v>2001</c:v>
-                </c:pt>
-                <c:pt idx="4">
-                  <c:v>2002</c:v>
-                </c:pt>
-                <c:pt idx="5">
-                  <c:v>2004</c:v>
-                </c:pt>
-                <c:pt idx="6">
-                  <c:v>2005</c:v>
-                </c:pt>
-                <c:pt idx="7">
-                  <c:v>2006</c:v>
-                </c:pt>
-                <c:pt idx="8">
-                  <c:v>2008</c:v>
-                </c:pt>
-                <c:pt idx="9">
-                  <c:v>2010</c:v>
-                </c:pt>
-                <c:pt idx="10">
-                  <c:v>2011</c:v>
-                </c:pt>
-                <c:pt idx="11">
-                  <c:v>2012</c:v>
-                </c:pt>
-                <c:pt idx="12">
-                  <c:v>2013</c:v>
-                </c:pt>
-                <c:pt idx="13">
-                  <c:v>2014</c:v>
-                </c:pt>
-                <c:pt idx="14">
-                  <c:v>2015</c:v>
-                </c:pt>
-                <c:pt idx="15">
-                  <c:v>2016</c:v>
-                </c:pt>
-                <c:pt idx="16">
-                  <c:v>2017</c:v>
-                </c:pt>
-                <c:pt idx="17">
-                  <c:v>2018</c:v>
-                </c:pt>
-                <c:pt idx="18">
-                  <c:v>2019</c:v>
-                </c:pt>
-                <c:pt idx="19">
-                  <c:v>2020</c:v>
-                </c:pt>
-                <c:pt idx="20">
-                  <c:v>2021</c:v>
-                </c:pt>
-                <c:pt idx="21">
-                  <c:v>2022</c:v>
-                </c:pt>
-                <c:pt idx="22">
-                  <c:v>2023</c:v>
-                </c:pt>
-                <c:pt idx="23">
-                  <c:v>2024</c:v>
-                </c:pt>
-                <c:pt idx="24">
-                  <c:v>2025</c:v>
-                </c:pt>
-                <c:pt idx="25">
-                  <c:v>2026</c:v>
-                </c:pt>
-              </c:strCache>
-            </c:strRef>
-          </c:cat>
-          <c:val>
-            <c:numRef>
-              <c:f>Sheet1!$D$2:$D$27</c:f>
-              <c:numCache>
-                <c:formatCode>General</c:formatCode>
-                <c:ptCount val="26"/>
-                <c:pt idx="0">
-                  <c:v>0</c:v>
-                </c:pt>
-                <c:pt idx="1">
-                  <c:v>0</c:v>
-                </c:pt>
-                <c:pt idx="2">
-                  <c:v>0</c:v>
-                </c:pt>
-                <c:pt idx="3">
-                  <c:v>0</c:v>
-                </c:pt>
-                <c:pt idx="4">
-                  <c:v>0</c:v>
-                </c:pt>
-                <c:pt idx="5">
-                  <c:v>0</c:v>
-                </c:pt>
-                <c:pt idx="6">
-                  <c:v>0</c:v>
-                </c:pt>
-                <c:pt idx="7">
-                  <c:v>0</c:v>
-                </c:pt>
-                <c:pt idx="8">
-                  <c:v>0</c:v>
-                </c:pt>
-                <c:pt idx="9">
-                  <c:v>0</c:v>
-                </c:pt>
-                <c:pt idx="10">
-                  <c:v>0</c:v>
-                </c:pt>
-                <c:pt idx="11">
-                  <c:v>0</c:v>
-                </c:pt>
-                <c:pt idx="12">
-                  <c:v>0</c:v>
-                </c:pt>
-                <c:pt idx="13">
-                  <c:v>1</c:v>
-                </c:pt>
-                <c:pt idx="14">
-                  <c:v>1</c:v>
-                </c:pt>
-                <c:pt idx="15">
-                  <c:v>1</c:v>
-                </c:pt>
-                <c:pt idx="16">
-                  <c:v>0</c:v>
-                </c:pt>
-                <c:pt idx="17">
-                  <c:v>6</c:v>
-                </c:pt>
-                <c:pt idx="18">
-                  <c:v>5</c:v>
-                </c:pt>
-                <c:pt idx="19">
-                  <c:v>1</c:v>
-                </c:pt>
-                <c:pt idx="20">
-                  <c:v>3</c:v>
-                </c:pt>
-                <c:pt idx="21">
-                  <c:v>2</c:v>
-                </c:pt>
-                <c:pt idx="22">
-                  <c:v>11</c:v>
-                </c:pt>
-                <c:pt idx="23">
-                  <c:v>15</c:v>
-                </c:pt>
-                <c:pt idx="24">
-                  <c:v>19</c:v>
-                </c:pt>
-                <c:pt idx="25">
-                  <c:v>8</c:v>
-                </c:pt>
-              </c:numCache>
-            </c:numRef>
-          </c:val>
-        </c:ser>
-        <c:ser>
-          <c:idx val="3"/>
-          <c:order val="3"/>
-          <c:tx>
-            <c:strRef>
-              <c:f>Sheet1!$E$1</c:f>
-              <c:strCache>
-                <c:ptCount val="1"/>
-                <c:pt idx="0">
-                  <c:v>Anesthesiology</c:v>
-                </c:pt>
-              </c:strCache>
-            </c:strRef>
-          </c:tx>
-          <c:spPr>
-            <a:solidFill>
-              <a:srgbClr val="16858C"/>
-            </a:solidFill>
-            <a:ln>
-              <a:solidFill>
-                <a:srgbClr val="16858C"/>
-              </a:solidFill>
-            </a:ln>
-          </c:spPr>
-          <c:cat>
-            <c:strRef>
-              <c:f>Sheet1!$A$2:$A$27</c:f>
-              <c:strCache>
-                <c:ptCount val="26"/>
-                <c:pt idx="0">
-                  <c:v>1995</c:v>
-                </c:pt>
-                <c:pt idx="1">
-                  <c:v>1997</c:v>
-                </c:pt>
-                <c:pt idx="2">
-                  <c:v>1998</c:v>
-                </c:pt>
-                <c:pt idx="3">
-                  <c:v>2001</c:v>
-                </c:pt>
-                <c:pt idx="4">
-                  <c:v>2002</c:v>
-                </c:pt>
-                <c:pt idx="5">
-                  <c:v>2004</c:v>
-                </c:pt>
-                <c:pt idx="6">
-                  <c:v>2005</c:v>
-                </c:pt>
-                <c:pt idx="7">
-                  <c:v>2006</c:v>
-                </c:pt>
-                <c:pt idx="8">
-                  <c:v>2008</c:v>
-                </c:pt>
-                <c:pt idx="9">
-                  <c:v>2010</c:v>
-                </c:pt>
-                <c:pt idx="10">
-                  <c:v>2011</c:v>
-                </c:pt>
-                <c:pt idx="11">
-                  <c:v>2012</c:v>
-                </c:pt>
-                <c:pt idx="12">
-                  <c:v>2013</c:v>
-                </c:pt>
-                <c:pt idx="13">
-                  <c:v>2014</c:v>
-                </c:pt>
-                <c:pt idx="14">
-                  <c:v>2015</c:v>
-                </c:pt>
-                <c:pt idx="15">
-                  <c:v>2016</c:v>
-                </c:pt>
-                <c:pt idx="16">
-                  <c:v>2017</c:v>
-                </c:pt>
-                <c:pt idx="17">
-                  <c:v>2018</c:v>
-                </c:pt>
-                <c:pt idx="18">
-                  <c:v>2019</c:v>
-                </c:pt>
-                <c:pt idx="19">
-                  <c:v>2020</c:v>
-                </c:pt>
-                <c:pt idx="20">
-                  <c:v>2021</c:v>
-                </c:pt>
-                <c:pt idx="21">
-                  <c:v>2022</c:v>
-                </c:pt>
-                <c:pt idx="22">
-                  <c:v>2023</c:v>
-                </c:pt>
-                <c:pt idx="23">
-                  <c:v>2024</c:v>
-                </c:pt>
-                <c:pt idx="24">
-                  <c:v>2025</c:v>
-                </c:pt>
-                <c:pt idx="25">
-                  <c:v>2026</c:v>
-                </c:pt>
-              </c:strCache>
-            </c:strRef>
-          </c:cat>
-          <c:val>
-            <c:numRef>
-              <c:f>Sheet1!$E$2:$E$27</c:f>
-              <c:numCache>
-                <c:formatCode>General</c:formatCode>
-                <c:ptCount val="26"/>
-                <c:pt idx="0">
-                  <c:v>0</c:v>
-                </c:pt>
-                <c:pt idx="1">
-                  <c:v>1</c:v>
-                </c:pt>
-                <c:pt idx="2">
-                  <c:v>0</c:v>
-                </c:pt>
-                <c:pt idx="3">
-                  <c:v>0</c:v>
-                </c:pt>
-                <c:pt idx="4">
-                  <c:v>0</c:v>
-                </c:pt>
-                <c:pt idx="5">
-                  <c:v>0</c:v>
-                </c:pt>
-                <c:pt idx="6">
-                  <c:v>0</c:v>
-                </c:pt>
-                <c:pt idx="7">
-                  <c:v>0</c:v>
-                </c:pt>
-                <c:pt idx="8">
-                  <c:v>0</c:v>
-                </c:pt>
-                <c:pt idx="9">
-                  <c:v>0</c:v>
-                </c:pt>
-                <c:pt idx="10">
-                  <c:v>0</c:v>
-                </c:pt>
-                <c:pt idx="11">
-                  <c:v>0</c:v>
-                </c:pt>
-                <c:pt idx="12">
-                  <c:v>0</c:v>
-                </c:pt>
-                <c:pt idx="13">
-                  <c:v>0</c:v>
-                </c:pt>
-                <c:pt idx="14">
-                  <c:v>2</c:v>
-                </c:pt>
-                <c:pt idx="15">
-                  <c:v>0</c:v>
-                </c:pt>
-                <c:pt idx="16">
-                  <c:v>1</c:v>
-                </c:pt>
-                <c:pt idx="17">
-                  <c:v>0</c:v>
-                </c:pt>
-                <c:pt idx="18">
-                  <c:v>1</c:v>
-                </c:pt>
-                <c:pt idx="19">
-                  <c:v>1</c:v>
-                </c:pt>
-                <c:pt idx="20">
-                  <c:v>0</c:v>
-                </c:pt>
-                <c:pt idx="21">
-                  <c:v>2</c:v>
-                </c:pt>
-                <c:pt idx="22">
-                  <c:v>5</c:v>
-                </c:pt>
-                <c:pt idx="23">
-                  <c:v>5</c:v>
-                </c:pt>
-                <c:pt idx="24">
-                  <c:v>8</c:v>
-                </c:pt>
-                <c:pt idx="25">
-                  <c:v>4</c:v>
-                </c:pt>
-              </c:numCache>
-            </c:numRef>
-          </c:val>
-        </c:ser>
-        <c:ser>
-          <c:idx val="4"/>
-          <c:order val="4"/>
-          <c:tx>
-            <c:strRef>
-              <c:f>Sheet1!$F$1</c:f>
-              <c:strCache>
-                <c:ptCount val="1"/>
-                <c:pt idx="0">
-                  <c:v>Gastroenterology-Urology</c:v>
-                </c:pt>
-              </c:strCache>
-            </c:strRef>
-          </c:tx>
-          <c:spPr>
-            <a:solidFill>
-              <a:srgbClr val="AD2458"/>
-            </a:solidFill>
-            <a:ln>
-              <a:solidFill>
-                <a:srgbClr val="AD2458"/>
-              </a:solidFill>
-            </a:ln>
-          </c:spPr>
-          <c:cat>
-            <c:strRef>
-              <c:f>Sheet1!$A$2:$A$27</c:f>
-              <c:strCache>
-                <c:ptCount val="26"/>
-                <c:pt idx="0">
-                  <c:v>1995</c:v>
-                </c:pt>
-                <c:pt idx="1">
-                  <c:v>1997</c:v>
-                </c:pt>
-                <c:pt idx="2">
-                  <c:v>1998</c:v>
-                </c:pt>
-                <c:pt idx="3">
-                  <c:v>2001</c:v>
-                </c:pt>
-                <c:pt idx="4">
-                  <c:v>2002</c:v>
-                </c:pt>
-                <c:pt idx="5">
-                  <c:v>2004</c:v>
-                </c:pt>
-                <c:pt idx="6">
-                  <c:v>2005</c:v>
-                </c:pt>
-                <c:pt idx="7">
-                  <c:v>2006</c:v>
-                </c:pt>
-                <c:pt idx="8">
-                  <c:v>2008</c:v>
-                </c:pt>
-                <c:pt idx="9">
-                  <c:v>2010</c:v>
-                </c:pt>
-                <c:pt idx="10">
-                  <c:v>2011</c:v>
-                </c:pt>
-                <c:pt idx="11">
-                  <c:v>2012</c:v>
-                </c:pt>
-                <c:pt idx="12">
-                  <c:v>2013</c:v>
-                </c:pt>
-                <c:pt idx="13">
-                  <c:v>2014</c:v>
-                </c:pt>
-                <c:pt idx="14">
-                  <c:v>2015</c:v>
-                </c:pt>
-                <c:pt idx="15">
-                  <c:v>2016</c:v>
-                </c:pt>
-                <c:pt idx="16">
-                  <c:v>2017</c:v>
-                </c:pt>
-                <c:pt idx="17">
-                  <c:v>2018</c:v>
-                </c:pt>
-                <c:pt idx="18">
-                  <c:v>2019</c:v>
-                </c:pt>
-                <c:pt idx="19">
-                  <c:v>2020</c:v>
-                </c:pt>
-                <c:pt idx="20">
-                  <c:v>2021</c:v>
-                </c:pt>
-                <c:pt idx="21">
-                  <c:v>2022</c:v>
-                </c:pt>
-                <c:pt idx="22">
-                  <c:v>2023</c:v>
-                </c:pt>
-                <c:pt idx="23">
-                  <c:v>2024</c:v>
-                </c:pt>
-                <c:pt idx="24">
-                  <c:v>2025</c:v>
-                </c:pt>
-                <c:pt idx="25">
-                  <c:v>2026</c:v>
-                </c:pt>
-              </c:strCache>
-            </c:strRef>
-          </c:cat>
-          <c:val>
-            <c:numRef>
-              <c:f>Sheet1!$F$2:$F$27</c:f>
-              <c:numCache>
-                <c:formatCode>General</c:formatCode>
-                <c:ptCount val="26"/>
-                <c:pt idx="0">
-                  <c:v>0</c:v>
-                </c:pt>
-                <c:pt idx="1">
-                  <c:v>0</c:v>
-                </c:pt>
-                <c:pt idx="2">
-                  <c:v>0</c:v>
-                </c:pt>
-                <c:pt idx="3">
-                  <c:v>0</c:v>
-                </c:pt>
-                <c:pt idx="4">
-                  <c:v>0</c:v>
-                </c:pt>
-                <c:pt idx="5">
-                  <c:v>0</c:v>
-                </c:pt>
-                <c:pt idx="6">
-                  <c:v>0</c:v>
-                </c:pt>
-                <c:pt idx="7">
-                  <c:v>0</c:v>
-                </c:pt>
-                <c:pt idx="8">
-                  <c:v>0</c:v>
-                </c:pt>
-                <c:pt idx="9">
-                  <c:v>0</c:v>
-                </c:pt>
-                <c:pt idx="10">
-                  <c:v>0</c:v>
-                </c:pt>
-                <c:pt idx="11">
-                  <c:v>0</c:v>
-                </c:pt>
-                <c:pt idx="12">
-                  <c:v>0</c:v>
-                </c:pt>
-                <c:pt idx="13">
-                  <c:v>0</c:v>
-                </c:pt>
-                <c:pt idx="14">
-                  <c:v>0</c:v>
-                </c:pt>
-                <c:pt idx="15">
-                  <c:v>0</c:v>
-                </c:pt>
-                <c:pt idx="16">
-                  <c:v>0</c:v>
-                </c:pt>
-                <c:pt idx="17">
-                  <c:v>1</c:v>
-                </c:pt>
-                <c:pt idx="18">
-                  <c:v>0</c:v>
-                </c:pt>
-                <c:pt idx="19">
-                  <c:v>0</c:v>
-                </c:pt>
-                <c:pt idx="20">
-                  <c:v>3</c:v>
-                </c:pt>
-                <c:pt idx="21">
-                  <c:v>1</c:v>
-                </c:pt>
-                <c:pt idx="22">
-                  <c:v>5</c:v>
-                </c:pt>
-                <c:pt idx="23">
-                  <c:v>5</c:v>
-                </c:pt>
-                <c:pt idx="24">
-                  <c:v>8</c:v>
-                </c:pt>
-                <c:pt idx="25">
-                  <c:v>4</c:v>
-                </c:pt>
-              </c:numCache>
-            </c:numRef>
-          </c:val>
-        </c:ser>
-        <c:ser>
-          <c:idx val="5"/>
-          <c:order val="5"/>
-          <c:tx>
-            <c:strRef>
-              <c:f>Sheet1!$G$1</c:f>
-              <c:strCache>
-                <c:ptCount val="1"/>
-                <c:pt idx="0">
-                  <c:v>Hematology</c:v>
-                </c:pt>
-              </c:strCache>
-            </c:strRef>
-          </c:tx>
-          <c:spPr>
-            <a:solidFill>
-              <a:srgbClr val="F3A62A"/>
-            </a:solidFill>
-            <a:ln>
-              <a:solidFill>
-                <a:srgbClr val="F3A62A"/>
-              </a:solidFill>
-            </a:ln>
-          </c:spPr>
-          <c:cat>
-            <c:strRef>
-              <c:f>Sheet1!$A$2:$A$27</c:f>
-              <c:strCache>
-                <c:ptCount val="26"/>
-                <c:pt idx="0">
-                  <c:v>1995</c:v>
-                </c:pt>
-                <c:pt idx="1">
-                  <c:v>1997</c:v>
-                </c:pt>
-                <c:pt idx="2">
-                  <c:v>1998</c:v>
-                </c:pt>
-                <c:pt idx="3">
-                  <c:v>2001</c:v>
-                </c:pt>
-                <c:pt idx="4">
-                  <c:v>2002</c:v>
-                </c:pt>
-                <c:pt idx="5">
-                  <c:v>2004</c:v>
-                </c:pt>
-                <c:pt idx="6">
-                  <c:v>2005</c:v>
-                </c:pt>
-                <c:pt idx="7">
-                  <c:v>2006</c:v>
-                </c:pt>
-                <c:pt idx="8">
-                  <c:v>2008</c:v>
-                </c:pt>
-                <c:pt idx="9">
-                  <c:v>2010</c:v>
-                </c:pt>
-                <c:pt idx="10">
-                  <c:v>2011</c:v>
-                </c:pt>
-                <c:pt idx="11">
-                  <c:v>2012</c:v>
-                </c:pt>
-                <c:pt idx="12">
-                  <c:v>2013</c:v>
-                </c:pt>
-                <c:pt idx="13">
-                  <c:v>2014</c:v>
-                </c:pt>
-                <c:pt idx="14">
-                  <c:v>2015</c:v>
-                </c:pt>
-                <c:pt idx="15">
-                  <c:v>2016</c:v>
-                </c:pt>
-                <c:pt idx="16">
-                  <c:v>2017</c:v>
-                </c:pt>
-                <c:pt idx="17">
-                  <c:v>2018</c:v>
-                </c:pt>
-                <c:pt idx="18">
-                  <c:v>2019</c:v>
-                </c:pt>
-                <c:pt idx="19">
-                  <c:v>2020</c:v>
-                </c:pt>
-                <c:pt idx="20">
-                  <c:v>2021</c:v>
-                </c:pt>
-                <c:pt idx="21">
-                  <c:v>2022</c:v>
-                </c:pt>
-                <c:pt idx="22">
-                  <c:v>2023</c:v>
-                </c:pt>
-                <c:pt idx="23">
-                  <c:v>2024</c:v>
-                </c:pt>
-                <c:pt idx="24">
-                  <c:v>2025</c:v>
-                </c:pt>
-                <c:pt idx="25">
-                  <c:v>2026</c:v>
-                </c:pt>
-              </c:strCache>
-            </c:strRef>
-          </c:cat>
-          <c:val>
-            <c:numRef>
-              <c:f>Sheet1!$G$2:$G$27</c:f>
-              <c:numCache>
-                <c:formatCode>General</c:formatCode>
-                <c:ptCount val="26"/>
-                <c:pt idx="0">
-                  <c:v>0</c:v>
-                </c:pt>
-                <c:pt idx="1">
-                  <c:v>0</c:v>
-                </c:pt>
-                <c:pt idx="2">
-                  <c:v>0</c:v>
-                </c:pt>
-                <c:pt idx="3">
-                  <c:v>1</c:v>
-                </c:pt>
-                <c:pt idx="4">
-                  <c:v>0</c:v>
-                </c:pt>
-                <c:pt idx="5">
-                  <c:v>1</c:v>
-                </c:pt>
-                <c:pt idx="6">
-                  <c:v>0</c:v>
-                </c:pt>
-                <c:pt idx="7">
-                  <c:v>0</c:v>
-                </c:pt>
-                <c:pt idx="8">
-                  <c:v>1</c:v>
-                </c:pt>
-                <c:pt idx="9">
-                  <c:v>1</c:v>
-                </c:pt>
-                <c:pt idx="10">
-                  <c:v>1</c:v>
-                </c:pt>
-                <c:pt idx="11">
-                  <c:v>0</c:v>
-                </c:pt>
-                <c:pt idx="12">
-                  <c:v>1</c:v>
-                </c:pt>
-                <c:pt idx="13">
-                  <c:v>0</c:v>
-                </c:pt>
-                <c:pt idx="14">
-                  <c:v>0</c:v>
-                </c:pt>
-                <c:pt idx="15">
-                  <c:v>0</c:v>
-                </c:pt>
-                <c:pt idx="16">
-                  <c:v>1</c:v>
-                </c:pt>
-                <c:pt idx="17">
-                  <c:v>2</c:v>
-                </c:pt>
-                <c:pt idx="18">
-                  <c:v>1</c:v>
-                </c:pt>
-                <c:pt idx="19">
-                  <c:v>3</c:v>
-                </c:pt>
-                <c:pt idx="20">
-                  <c:v>0</c:v>
-                </c:pt>
-                <c:pt idx="21">
-                  <c:v>2</c:v>
-                </c:pt>
-                <c:pt idx="22">
-                  <c:v>1</c:v>
-                </c:pt>
-                <c:pt idx="23">
-                  <c:v>1</c:v>
-                </c:pt>
-                <c:pt idx="24">
-                  <c:v>3</c:v>
-                </c:pt>
-                <c:pt idx="25">
-                  <c:v>2</c:v>
-                </c:pt>
-              </c:numCache>
-            </c:numRef>
-          </c:val>
-        </c:ser>
-        <c:ser>
-          <c:idx val="6"/>
-          <c:order val="6"/>
-          <c:tx>
-            <c:strRef>
-              <c:f>Sheet1!$H$1</c:f>
-              <c:strCache>
-                <c:ptCount val="1"/>
-                <c:pt idx="0">
-                  <c:v>Pathology</c:v>
-                </c:pt>
-              </c:strCache>
-            </c:strRef>
-          </c:tx>
-          <c:spPr>
-            <a:solidFill>
-              <a:srgbClr val="3E8B45"/>
-            </a:solidFill>
-            <a:ln>
-              <a:solidFill>
-                <a:srgbClr val="3E8B45"/>
-              </a:solidFill>
-            </a:ln>
-          </c:spPr>
-          <c:cat>
-            <c:strRef>
-              <c:f>Sheet1!$A$2:$A$27</c:f>
-              <c:strCache>
-                <c:ptCount val="26"/>
-                <c:pt idx="0">
-                  <c:v>1995</c:v>
-                </c:pt>
-                <c:pt idx="1">
-                  <c:v>1997</c:v>
-                </c:pt>
-                <c:pt idx="2">
-                  <c:v>1998</c:v>
-                </c:pt>
-                <c:pt idx="3">
-                  <c:v>2001</c:v>
-                </c:pt>
-                <c:pt idx="4">
-                  <c:v>2002</c:v>
-                </c:pt>
-                <c:pt idx="5">
-                  <c:v>2004</c:v>
-                </c:pt>
-                <c:pt idx="6">
-                  <c:v>2005</c:v>
-                </c:pt>
-                <c:pt idx="7">
-                  <c:v>2006</c:v>
-                </c:pt>
-                <c:pt idx="8">
-                  <c:v>2008</c:v>
-                </c:pt>
-                <c:pt idx="9">
-                  <c:v>2010</c:v>
-                </c:pt>
-                <c:pt idx="10">
-                  <c:v>2011</c:v>
-                </c:pt>
-                <c:pt idx="11">
-                  <c:v>2012</c:v>
-                </c:pt>
-                <c:pt idx="12">
-                  <c:v>2013</c:v>
-                </c:pt>
-                <c:pt idx="13">
-                  <c:v>2014</c:v>
-                </c:pt>
-                <c:pt idx="14">
-                  <c:v>2015</c:v>
-                </c:pt>
-                <c:pt idx="15">
-                  <c:v>2016</c:v>
-                </c:pt>
-                <c:pt idx="16">
-                  <c:v>2017</c:v>
-                </c:pt>
-                <c:pt idx="17">
-                  <c:v>2018</c:v>
-                </c:pt>
-                <c:pt idx="18">
-                  <c:v>2019</c:v>
-                </c:pt>
-                <c:pt idx="19">
-                  <c:v>2020</c:v>
-                </c:pt>
-                <c:pt idx="20">
-                  <c:v>2021</c:v>
-                </c:pt>
-                <c:pt idx="21">
-                  <c:v>2022</c:v>
-                </c:pt>
-                <c:pt idx="22">
-                  <c:v>2023</c:v>
-                </c:pt>
-                <c:pt idx="23">
-                  <c:v>2024</c:v>
-                </c:pt>
-                <c:pt idx="24">
-                  <c:v>2025</c:v>
-                </c:pt>
-                <c:pt idx="25">
-                  <c:v>2026</c:v>
-                </c:pt>
-              </c:strCache>
-            </c:strRef>
-          </c:cat>
-          <c:val>
-            <c:numRef>
-              <c:f>Sheet1!$H$2:$H$27</c:f>
-              <c:numCache>
-                <c:formatCode>General</c:formatCode>
-                <c:ptCount val="26"/>
-                <c:pt idx="0">
-                  <c:v>2</c:v>
-                </c:pt>
-                <c:pt idx="1">
-                  <c:v>0</c:v>
-                </c:pt>
-                <c:pt idx="2">
-                  <c:v>0</c:v>
-                </c:pt>
-                <c:pt idx="3">
-                  <c:v>0</c:v>
-                </c:pt>
-                <c:pt idx="4">
-                  <c:v>0</c:v>
-                </c:pt>
-                <c:pt idx="5">
-                  <c:v>0</c:v>
-                </c:pt>
-                <c:pt idx="6">
-                  <c:v>0</c:v>
-                </c:pt>
-                <c:pt idx="7">
-                  <c:v>0</c:v>
-                </c:pt>
-                <c:pt idx="8">
-                  <c:v>0</c:v>
-                </c:pt>
-                <c:pt idx="9">
-                  <c:v>0</c:v>
-                </c:pt>
-                <c:pt idx="10">
-                  <c:v>0</c:v>
-                </c:pt>
-                <c:pt idx="11">
-                  <c:v>0</c:v>
-                </c:pt>
-                <c:pt idx="12">
-                  <c:v>0</c:v>
-                </c:pt>
-                <c:pt idx="13">
-                  <c:v>0</c:v>
-                </c:pt>
-                <c:pt idx="14">
-                  <c:v>0</c:v>
-                </c:pt>
-                <c:pt idx="15">
-                  <c:v>0</c:v>
-                </c:pt>
-                <c:pt idx="16">
-                  <c:v>0</c:v>
-                </c:pt>
-                <c:pt idx="17">
-                  <c:v>0</c:v>
-                </c:pt>
-                <c:pt idx="18">
-                  <c:v>0</c:v>
-                </c:pt>
-                <c:pt idx="19">
-                  <c:v>0</c:v>
-                </c:pt>
-                <c:pt idx="20">
-                  <c:v>1</c:v>
-                </c:pt>
-                <c:pt idx="21">
-                  <c:v>0</c:v>
-                </c:pt>
-                <c:pt idx="22">
-                  <c:v>1</c:v>
-                </c:pt>
-                <c:pt idx="23">
-                  <c:v>1</c:v>
-                </c:pt>
-                <c:pt idx="24">
-                  <c:v>4</c:v>
-                </c:pt>
-                <c:pt idx="25">
-                  <c:v>1</c:v>
-                </c:pt>
-              </c:numCache>
-            </c:numRef>
-          </c:val>
-        </c:ser>
-        <c:ser>
-          <c:idx val="7"/>
-          <c:order val="7"/>
-          <c:tx>
-            <c:strRef>
-              <c:f>Sheet1!$I$1</c:f>
-              <c:strCache>
-                <c:ptCount val="1"/>
-                <c:pt idx="0">
-                  <c:v>Ophthalmic</c:v>
-                </c:pt>
-              </c:strCache>
-            </c:strRef>
-          </c:tx>
-          <c:spPr>
-            <a:solidFill>
-              <a:srgbClr val="6A2CA0"/>
-            </a:solidFill>
-            <a:ln>
-              <a:solidFill>
-                <a:srgbClr val="6A2CA0"/>
-              </a:solidFill>
-            </a:ln>
-          </c:spPr>
-          <c:cat>
-            <c:strRef>
-              <c:f>Sheet1!$A$2:$A$27</c:f>
-              <c:strCache>
-                <c:ptCount val="26"/>
-                <c:pt idx="0">
-                  <c:v>1995</c:v>
-                </c:pt>
-                <c:pt idx="1">
-                  <c:v>1997</c:v>
-                </c:pt>
-                <c:pt idx="2">
-                  <c:v>1998</c:v>
-                </c:pt>
-                <c:pt idx="3">
-                  <c:v>2001</c:v>
-                </c:pt>
-                <c:pt idx="4">
-                  <c:v>2002</c:v>
-                </c:pt>
-                <c:pt idx="5">
-                  <c:v>2004</c:v>
-                </c:pt>
-                <c:pt idx="6">
-                  <c:v>2005</c:v>
-                </c:pt>
-                <c:pt idx="7">
-                  <c:v>2006</c:v>
-                </c:pt>
-                <c:pt idx="8">
-                  <c:v>2008</c:v>
-                </c:pt>
-                <c:pt idx="9">
-                  <c:v>2010</c:v>
-                </c:pt>
-                <c:pt idx="10">
-                  <c:v>2011</c:v>
-                </c:pt>
-                <c:pt idx="11">
-                  <c:v>2012</c:v>
-                </c:pt>
-                <c:pt idx="12">
-                  <c:v>2013</c:v>
-                </c:pt>
-                <c:pt idx="13">
-                  <c:v>2014</c:v>
-                </c:pt>
-                <c:pt idx="14">
-                  <c:v>2015</c:v>
-                </c:pt>
-                <c:pt idx="15">
-                  <c:v>2016</c:v>
-                </c:pt>
-                <c:pt idx="16">
-                  <c:v>2017</c:v>
-                </c:pt>
-                <c:pt idx="17">
-                  <c:v>2018</c:v>
-                </c:pt>
-                <c:pt idx="18">
-                  <c:v>2019</c:v>
-                </c:pt>
-                <c:pt idx="19">
-                  <c:v>2020</c:v>
-                </c:pt>
-                <c:pt idx="20">
-                  <c:v>2021</c:v>
-                </c:pt>
-                <c:pt idx="21">
-                  <c:v>2022</c:v>
-                </c:pt>
-                <c:pt idx="22">
-                  <c:v>2023</c:v>
-                </c:pt>
-                <c:pt idx="23">
-                  <c:v>2024</c:v>
-                </c:pt>
-                <c:pt idx="24">
-                  <c:v>2025</c:v>
-                </c:pt>
-                <c:pt idx="25">
-                  <c:v>2026</c:v>
-                </c:pt>
-              </c:strCache>
-            </c:strRef>
-          </c:cat>
-          <c:val>
-            <c:numRef>
-              <c:f>Sheet1!$I$2:$I$27</c:f>
-              <c:numCache>
-                <c:formatCode>General</c:formatCode>
-                <c:ptCount val="26"/>
-                <c:pt idx="0">
-                  <c:v>0</c:v>
-                </c:pt>
-                <c:pt idx="1">
-                  <c:v>0</c:v>
-                </c:pt>
-                <c:pt idx="2">
-                  <c:v>0</c:v>
-                </c:pt>
-                <c:pt idx="3">
-                  <c:v>0</c:v>
-                </c:pt>
-                <c:pt idx="4">
-                  <c:v>0</c:v>
-                </c:pt>
-                <c:pt idx="5">
-                  <c:v>0</c:v>
-                </c:pt>
-                <c:pt idx="6">
-                  <c:v>0</c:v>
-                </c:pt>
-                <c:pt idx="7">
-                  <c:v>0</c:v>
-                </c:pt>
-                <c:pt idx="8">
-                  <c:v>0</c:v>
-                </c:pt>
-                <c:pt idx="9">
-                  <c:v>0</c:v>
-                </c:pt>
-                <c:pt idx="10">
-                  <c:v>0</c:v>
-                </c:pt>
-                <c:pt idx="11">
-                  <c:v>0</c:v>
-                </c:pt>
-                <c:pt idx="12">
-                  <c:v>0</c:v>
-                </c:pt>
-                <c:pt idx="13">
-                  <c:v>0</c:v>
-                </c:pt>
-                <c:pt idx="14">
-                  <c:v>0</c:v>
-                </c:pt>
-                <c:pt idx="15">
-                  <c:v>0</c:v>
-                </c:pt>
-                <c:pt idx="16">
-                  <c:v>0</c:v>
-                </c:pt>
-                <c:pt idx="17">
-                  <c:v>1</c:v>
-                </c:pt>
-                <c:pt idx="18">
-                  <c:v>1</c:v>
-                </c:pt>
-                <c:pt idx="19">
-                  <c:v>1</c:v>
-                </c:pt>
-                <c:pt idx="20">
-                  <c:v>1</c:v>
-                </c:pt>
-                <c:pt idx="21">
-                  <c:v>2</c:v>
-                </c:pt>
-                <c:pt idx="22">
-                  <c:v>1</c:v>
-                </c:pt>
-                <c:pt idx="23">
-                  <c:v>2</c:v>
-                </c:pt>
-                <c:pt idx="24">
-                  <c:v>1</c:v>
-                </c:pt>
-                <c:pt idx="25">
-                  <c:v>0</c:v>
-                </c:pt>
-              </c:numCache>
-            </c:numRef>
-          </c:val>
-        </c:ser>
-        <c:ser>
-          <c:idx val="8"/>
-          <c:order val="8"/>
-          <c:tx>
-            <c:strRef>
-              <c:f>Sheet1!$J$1</c:f>
-              <c:strCache>
-                <c:ptCount val="1"/>
-                <c:pt idx="0">
-                  <c:v>General and Plastic Surgery</c:v>
-                </c:pt>
-              </c:strCache>
-            </c:strRef>
-          </c:tx>
-          <c:spPr>
-            <a:solidFill>
-              <a:srgbClr val="4B2CA3"/>
-            </a:solidFill>
-            <a:ln>
-              <a:solidFill>
-                <a:srgbClr val="4B2CA3"/>
-              </a:solidFill>
-            </a:ln>
-          </c:spPr>
-          <c:cat>
-            <c:strRef>
-              <c:f>Sheet1!$A$2:$A$27</c:f>
-              <c:strCache>
-                <c:ptCount val="26"/>
-                <c:pt idx="0">
-                  <c:v>1995</c:v>
-                </c:pt>
-                <c:pt idx="1">
-                  <c:v>1997</c:v>
-                </c:pt>
-                <c:pt idx="2">
-                  <c:v>1998</c:v>
-                </c:pt>
-                <c:pt idx="3">
-                  <c:v>2001</c:v>
-                </c:pt>
-                <c:pt idx="4">
-                  <c:v>2002</c:v>
-                </c:pt>
-                <c:pt idx="5">
-                  <c:v>2004</c:v>
-                </c:pt>
-                <c:pt idx="6">
-                  <c:v>2005</c:v>
-                </c:pt>
-                <c:pt idx="7">
-                  <c:v>2006</c:v>
-                </c:pt>
-                <c:pt idx="8">
-                  <c:v>2008</c:v>
-                </c:pt>
-                <c:pt idx="9">
-                  <c:v>2010</c:v>
-                </c:pt>
-                <c:pt idx="10">
-                  <c:v>2011</c:v>
-                </c:pt>
-                <c:pt idx="11">
-                  <c:v>2012</c:v>
-                </c:pt>
-                <c:pt idx="12">
-                  <c:v>2013</c:v>
-                </c:pt>
-                <c:pt idx="13">
-                  <c:v>2014</c:v>
-                </c:pt>
-                <c:pt idx="14">
-                  <c:v>2015</c:v>
-                </c:pt>
-                <c:pt idx="15">
-                  <c:v>2016</c:v>
-                </c:pt>
-                <c:pt idx="16">
-                  <c:v>2017</c:v>
-                </c:pt>
-                <c:pt idx="17">
-                  <c:v>2018</c:v>
-                </c:pt>
-                <c:pt idx="18">
-                  <c:v>2019</c:v>
-                </c:pt>
-                <c:pt idx="19">
-                  <c:v>2020</c:v>
-                </c:pt>
-                <c:pt idx="20">
-                  <c:v>2021</c:v>
-                </c:pt>
-                <c:pt idx="21">
-                  <c:v>2022</c:v>
-                </c:pt>
-                <c:pt idx="22">
-                  <c:v>2023</c:v>
-                </c:pt>
-                <c:pt idx="23">
-                  <c:v>2024</c:v>
-                </c:pt>
-                <c:pt idx="24">
-                  <c:v>2025</c:v>
-                </c:pt>
-                <c:pt idx="25">
-                  <c:v>2026</c:v>
-                </c:pt>
-              </c:strCache>
-            </c:strRef>
-          </c:cat>
-          <c:val>
-            <c:numRef>
-              <c:f>Sheet1!$J$2:$J$27</c:f>
-              <c:numCache>
-                <c:formatCode>General</c:formatCode>
-                <c:ptCount val="26"/>
-                <c:pt idx="0">
-                  <c:v>0</c:v>
-                </c:pt>
-                <c:pt idx="1">
-                  <c:v>0</c:v>
-                </c:pt>
-                <c:pt idx="2">
-                  <c:v>0</c:v>
-                </c:pt>
-                <c:pt idx="3">
-                  <c:v>0</c:v>
-                </c:pt>
-                <c:pt idx="4">
-                  <c:v>0</c:v>
-                </c:pt>
-                <c:pt idx="5">
-                  <c:v>0</c:v>
-                </c:pt>
-                <c:pt idx="6">
-                  <c:v>0</c:v>
-                </c:pt>
-                <c:pt idx="7">
-                  <c:v>0</c:v>
-                </c:pt>
-                <c:pt idx="8">
-                  <c:v>0</c:v>
-                </c:pt>
-                <c:pt idx="9">
-                  <c:v>0</c:v>
-                </c:pt>
-                <c:pt idx="10">
-                  <c:v>1</c:v>
-                </c:pt>
-                <c:pt idx="11">
-                  <c:v>1</c:v>
-                </c:pt>
-                <c:pt idx="12">
-                  <c:v>0</c:v>
-                </c:pt>
-                <c:pt idx="13">
-                  <c:v>0</c:v>
-                </c:pt>
-                <c:pt idx="14">
-                  <c:v>0</c:v>
-                </c:pt>
-                <c:pt idx="15">
-                  <c:v>0</c:v>
-                </c:pt>
-                <c:pt idx="16">
-                  <c:v>1</c:v>
-                </c:pt>
-                <c:pt idx="17">
-                  <c:v>0</c:v>
-                </c:pt>
-                <c:pt idx="18">
-                  <c:v>0</c:v>
-                </c:pt>
-                <c:pt idx="19">
-                  <c:v>0</c:v>
-                </c:pt>
-                <c:pt idx="20">
-                  <c:v>0</c:v>
-                </c:pt>
-                <c:pt idx="21">
-                  <c:v>0</c:v>
-                </c:pt>
-                <c:pt idx="22">
-                  <c:v>0</c:v>
-                </c:pt>
-                <c:pt idx="23">
-                  <c:v>2</c:v>
-                </c:pt>
-                <c:pt idx="24">
-                  <c:v>2</c:v>
-                </c:pt>
-                <c:pt idx="25">
-                  <c:v>2</c:v>
-                </c:pt>
-              </c:numCache>
-            </c:numRef>
-          </c:val>
-        </c:ser>
-        <c:ser>
-          <c:idx val="9"/>
-          <c:order val="9"/>
-          <c:tx>
-            <c:strRef>
-              <c:f>Sheet1!$K$1</c:f>
-              <c:strCache>
-                <c:ptCount val="1"/>
-                <c:pt idx="0">
-                  <c:v>Other</c:v>
-                </c:pt>
-              </c:strCache>
-            </c:strRef>
-          </c:tx>
-          <c:spPr>
-            <a:solidFill>
-              <a:srgbClr val="14725E"/>
-            </a:solidFill>
-            <a:ln>
-              <a:solidFill>
-                <a:srgbClr val="14725E"/>
-              </a:solidFill>
-            </a:ln>
-          </c:spPr>
-          <c:cat>
-            <c:strRef>
-              <c:f>Sheet1!$A$2:$A$27</c:f>
-              <c:strCache>
-                <c:ptCount val="26"/>
-                <c:pt idx="0">
-                  <c:v>1995</c:v>
-                </c:pt>
-                <c:pt idx="1">
-                  <c:v>1997</c:v>
-                </c:pt>
-                <c:pt idx="2">
-                  <c:v>1998</c:v>
-                </c:pt>
-                <c:pt idx="3">
-                  <c:v>2001</c:v>
-                </c:pt>
-                <c:pt idx="4">
-                  <c:v>2002</c:v>
-                </c:pt>
-                <c:pt idx="5">
-                  <c:v>2004</c:v>
-                </c:pt>
-                <c:pt idx="6">
-                  <c:v>2005</c:v>
-                </c:pt>
-                <c:pt idx="7">
-                  <c:v>2006</c:v>
-                </c:pt>
-                <c:pt idx="8">
-                  <c:v>2008</c:v>
-                </c:pt>
-                <c:pt idx="9">
-                  <c:v>2010</c:v>
-                </c:pt>
-                <c:pt idx="10">
-                  <c:v>2011</c:v>
-                </c:pt>
-                <c:pt idx="11">
-                  <c:v>2012</c:v>
-                </c:pt>
-                <c:pt idx="12">
-                  <c:v>2013</c:v>
-                </c:pt>
-                <c:pt idx="13">
-                  <c:v>2014</c:v>
-                </c:pt>
-                <c:pt idx="14">
-                  <c:v>2015</c:v>
-                </c:pt>
-                <c:pt idx="15">
-                  <c:v>2016</c:v>
-                </c:pt>
-                <c:pt idx="16">
-                  <c:v>2017</c:v>
-                </c:pt>
-                <c:pt idx="17">
-                  <c:v>2018</c:v>
-                </c:pt>
-                <c:pt idx="18">
-                  <c:v>2019</c:v>
-                </c:pt>
-                <c:pt idx="19">
-                  <c:v>2020</c:v>
-                </c:pt>
-                <c:pt idx="20">
-                  <c:v>2021</c:v>
-                </c:pt>
-                <c:pt idx="21">
-                  <c:v>2022</c:v>
-                </c:pt>
-                <c:pt idx="22">
-                  <c:v>2023</c:v>
-                </c:pt>
-                <c:pt idx="23">
-                  <c:v>2024</c:v>
-                </c:pt>
-                <c:pt idx="24">
-                  <c:v>2025</c:v>
-                </c:pt>
-                <c:pt idx="25">
-                  <c:v>2026</c:v>
-                </c:pt>
-              </c:strCache>
-            </c:strRef>
-          </c:cat>
-          <c:val>
-            <c:numRef>
               <c:f>Sheet1!$K$2:$K$27</c:f>
               <c:numCache>
                 <c:formatCode>General</c:formatCode>
@@ -2021,76 +2021,76 @@
                   <c:v>0</c:v>
                 </c:pt>
                 <c:pt idx="2">
-                  <c:v>0</c:v>
+                  <c:v>2</c:v>
                 </c:pt>
                 <c:pt idx="3">
-                  <c:v>0</c:v>
+                  <c:v>1</c:v>
                 </c:pt>
                 <c:pt idx="4">
-                  <c:v>0</c:v>
+                  <c:v>1</c:v>
                 </c:pt>
                 <c:pt idx="5">
                   <c:v>0</c:v>
                 </c:pt>
                 <c:pt idx="6">
+                  <c:v>0</c:v>
+                </c:pt>
+                <c:pt idx="7">
+                  <c:v>0</c:v>
+                </c:pt>
+                <c:pt idx="8">
+                  <c:v>2</c:v>
+                </c:pt>
+                <c:pt idx="9">
+                  <c:v>0</c:v>
+                </c:pt>
+                <c:pt idx="10">
                   <c:v>1</c:v>
                 </c:pt>
-                <c:pt idx="7">
-                  <c:v>1</c:v>
-                </c:pt>
-                <c:pt idx="8">
-                  <c:v>1</c:v>
-                </c:pt>
-                <c:pt idx="9">
-                  <c:v>1</c:v>
-                </c:pt>
-                <c:pt idx="10">
-                  <c:v>0</c:v>
-                </c:pt>
                 <c:pt idx="11">
-                  <c:v>1</c:v>
+                  <c:v>2</c:v>
                 </c:pt>
                 <c:pt idx="12">
-                  <c:v>2</c:v>
+                  <c:v>0</c:v>
                 </c:pt>
                 <c:pt idx="13">
-                  <c:v>0</c:v>
+                  <c:v>5</c:v>
                 </c:pt>
                 <c:pt idx="14">
                   <c:v>1</c:v>
                 </c:pt>
                 <c:pt idx="15">
-                  <c:v>2</c:v>
+                  <c:v>11</c:v>
                 </c:pt>
                 <c:pt idx="16">
-                  <c:v>1</c:v>
+                  <c:v>16</c:v>
                 </c:pt>
                 <c:pt idx="17">
-                  <c:v>5</c:v>
+                  <c:v>40</c:v>
                 </c:pt>
                 <c:pt idx="18">
-                  <c:v>6</c:v>
+                  <c:v>51</c:v>
                 </c:pt>
                 <c:pt idx="19">
-                  <c:v>1</c:v>
+                  <c:v>99</c:v>
                 </c:pt>
                 <c:pt idx="20">
-                  <c:v>0</c:v>
+                  <c:v>110</c:v>
                 </c:pt>
                 <c:pt idx="21">
-                  <c:v>1</c:v>
+                  <c:v>138</c:v>
                 </c:pt>
                 <c:pt idx="22">
-                  <c:v>3</c:v>
+                  <c:v>178</c:v>
                 </c:pt>
                 <c:pt idx="23">
-                  <c:v>6</c:v>
+                  <c:v>183</c:v>
                 </c:pt>
                 <c:pt idx="24">
-                  <c:v>6</c:v>
+                  <c:v>254</c:v>
                 </c:pt>
                 <c:pt idx="25">
-                  <c:v>10</c:v>
+                  <c:v>135</c:v>
                 </c:pt>
               </c:numCache>
             </c:numRef>
@@ -2115,7 +2115,7 @@
           <a:lstStyle/>
           <a:p>
             <a:pPr>
-              <a:defRPr sz="700"/>
+              <a:defRPr sz="680"/>
             </a:pPr>
           </a:p>
         </c:txPr>
@@ -2166,10 +2166,6 @@
         <c:crosses val="autoZero"/>
       </c:valAx>
     </c:plotArea>
-    <c:legend>
-      <c:legendPos/>
-      <c:overlay val="0"/>
-    </c:legend>
     <c:dispBlanksAs val="gap"/>
   </c:chart>
   <c:txPr>
@@ -5185,7 +5181,7 @@
         </p:nvSpPr>
         <p:spPr>
           <a:xfrm>
-            <a:off x="502920" y="292608"/>
+            <a:off x="502920" y="256032"/>
             <a:ext cx="6949440" cy="347472"/>
           </a:xfrm>
           <a:prstGeom prst="rect">
@@ -5194,8 +5190,8 @@
           <a:noFill/>
         </p:spPr>
         <p:txBody>
-          <a:bodyPr wrap="none" lIns="0" rIns="0" tIns="0" bIns="0">
-            <a:spAutoFit/>
+          <a:bodyPr wrap="square" lIns="0" rIns="0" tIns="0" bIns="0">
+            <a:noAutofit/>
           </a:bodyPr>
           <a:lstStyle/>
           <a:p>
@@ -5220,7 +5216,7 @@
         </p:nvSpPr>
         <p:spPr>
           <a:xfrm>
-            <a:off x="502920" y="685800"/>
+            <a:off x="502920" y="658368"/>
             <a:ext cx="7040880" cy="219456"/>
           </a:xfrm>
           <a:prstGeom prst="rect">
@@ -5229,8 +5225,8 @@
           <a:noFill/>
         </p:spPr>
         <p:txBody>
-          <a:bodyPr wrap="none" lIns="0" rIns="0" tIns="0" bIns="0">
-            <a:spAutoFit/>
+          <a:bodyPr wrap="square" lIns="0" rIns="0" tIns="0" bIns="0">
+            <a:noAutofit/>
           </a:bodyPr>
           <a:lstStyle/>
           <a:p>
@@ -5255,7 +5251,7 @@
         </p:nvSpPr>
         <p:spPr>
           <a:xfrm>
-            <a:off x="502920" y="941832"/>
+            <a:off x="502920" y="914400"/>
             <a:ext cx="7680960" cy="210312"/>
           </a:xfrm>
           <a:prstGeom prst="rect">
@@ -5264,20 +5260,20 @@
           <a:noFill/>
         </p:spPr>
         <p:txBody>
-          <a:bodyPr wrap="none" lIns="0" rIns="0" tIns="0" bIns="0">
-            <a:spAutoFit/>
+          <a:bodyPr wrap="square" lIns="0" rIns="0" tIns="0" bIns="0">
+            <a:noAutofit/>
           </a:bodyPr>
           <a:lstStyle/>
           <a:p>
             <a:pPr algn="l"/>
             <a:r>
-              <a:rPr sz="850" b="0" i="0">
+              <a:rPr sz="830" b="0" i="0">
                 <a:solidFill>
                   <a:srgbClr val="64748B"/>
                 </a:solidFill>
                 <a:latin typeface="Aptos"/>
               </a:rPr>
-              <a:t>Source data: U.S. Food and Drug Administration AI-Enabled Medical Devices List CSV</a:t>
+              <a:t>Source: U.S. Food and Drug Administration AI-Enabled Medical Devices List CSV; adapted by AI2Practice for educational use.</a:t>
             </a:r>
           </a:p>
         </p:txBody>
@@ -5344,8 +5340,8 @@
           <a:noFill/>
         </p:spPr>
         <p:txBody>
-          <a:bodyPr wrap="none" lIns="0" rIns="0" tIns="0" bIns="0">
-            <a:spAutoFit/>
+          <a:bodyPr wrap="square" lIns="0" rIns="0" tIns="0" bIns="0">
+            <a:noAutofit/>
           </a:bodyPr>
           <a:lstStyle/>
           <a:p>
@@ -5379,8 +5375,8 @@
           <a:noFill/>
         </p:spPr>
         <p:txBody>
-          <a:bodyPr wrap="none" lIns="0" rIns="0" tIns="0" bIns="0">
-            <a:spAutoFit/>
+          <a:bodyPr wrap="square" lIns="0" rIns="0" tIns="0" bIns="0">
+            <a:noAutofit/>
           </a:bodyPr>
           <a:lstStyle/>
           <a:p>
@@ -5459,8 +5455,8 @@
           <a:noFill/>
         </p:spPr>
         <p:txBody>
-          <a:bodyPr wrap="none" lIns="0" rIns="0" tIns="0" bIns="0">
-            <a:spAutoFit/>
+          <a:bodyPr wrap="square" lIns="0" rIns="0" tIns="0" bIns="0">
+            <a:noAutofit/>
           </a:bodyPr>
           <a:lstStyle/>
           <a:p>
@@ -5494,8 +5490,8 @@
           <a:noFill/>
         </p:spPr>
         <p:txBody>
-          <a:bodyPr wrap="none" lIns="0" rIns="0" tIns="0" bIns="0">
-            <a:spAutoFit/>
+          <a:bodyPr wrap="square" lIns="0" rIns="0" tIns="0" bIns="0">
+            <a:noAutofit/>
           </a:bodyPr>
           <a:lstStyle/>
           <a:p>
@@ -5574,8 +5570,8 @@
           <a:noFill/>
         </p:spPr>
         <p:txBody>
-          <a:bodyPr wrap="none" lIns="0" rIns="0" tIns="0" bIns="0">
-            <a:spAutoFit/>
+          <a:bodyPr wrap="square" lIns="0" rIns="0" tIns="0" bIns="0">
+            <a:noAutofit/>
           </a:bodyPr>
           <a:lstStyle/>
           <a:p>
@@ -5609,8 +5605,8 @@
           <a:noFill/>
         </p:spPr>
         <p:txBody>
-          <a:bodyPr wrap="none" lIns="0" rIns="0" tIns="0" bIns="0">
-            <a:spAutoFit/>
+          <a:bodyPr wrap="square" lIns="0" rIns="0" tIns="0" bIns="0">
+            <a:noAutofit/>
           </a:bodyPr>
           <a:lstStyle/>
           <a:p>
@@ -5636,8 +5632,8 @@
           <p:nvPr/>
         </p:nvGraphicFramePr>
         <p:xfrm>
-          <a:off x="502920" y="1298448"/>
-          <a:ext cx="9189720" cy="4160520"/>
+          <a:off x="502920" y="1225296"/>
+          <a:ext cx="7479792" cy="4160520"/>
         </p:xfrm>
         <a:graphic>
           <a:graphicData uri="http://schemas.openxmlformats.org/drawingml/2006/chart">
@@ -5647,13 +5643,836 @@
       </p:graphicFrame>
       <p:sp>
         <p:nvSpPr>
-          <p:cNvPr id="15" name="TextBox 14"/>
+          <p:cNvPr id="15" name="Rectangle 14"/>
+          <p:cNvSpPr/>
+          <p:nvPr/>
+        </p:nvSpPr>
+        <p:spPr>
+          <a:xfrm>
+            <a:off x="8485632" y="1188720"/>
+            <a:ext cx="2999232" cy="246888"/>
+          </a:xfrm>
+          <a:prstGeom prst="rect">
+            <a:avLst/>
+          </a:prstGeom>
+          <a:solidFill>
+            <a:srgbClr val="FFF56A"/>
+          </a:solidFill>
+          <a:ln>
+            <a:noFill/>
+          </a:ln>
+        </p:spPr>
+        <p:style>
+          <a:lnRef idx="1">
+            <a:schemeClr val="accent1"/>
+          </a:lnRef>
+          <a:fillRef idx="3">
+            <a:schemeClr val="accent1"/>
+          </a:fillRef>
+          <a:effectRef idx="2">
+            <a:schemeClr val="accent1"/>
+          </a:effectRef>
+          <a:fontRef idx="minor">
+            <a:schemeClr val="lt1"/>
+          </a:fontRef>
+        </p:style>
+        <p:txBody>
+          <a:bodyPr rtlCol="0" anchor="ctr"/>
+          <a:lstStyle/>
+          <a:p>
+            <a:pPr algn="ctr"/>
+          </a:p>
+        </p:txBody>
+      </p:sp>
+      <p:sp>
+        <p:nvSpPr>
+          <p:cNvPr id="16" name="Rectangle 15"/>
+          <p:cNvSpPr/>
+          <p:nvPr/>
+        </p:nvSpPr>
+        <p:spPr>
+          <a:xfrm>
+            <a:off x="8275320" y="1239012"/>
+            <a:ext cx="100584" cy="100584"/>
+          </a:xfrm>
+          <a:prstGeom prst="rect">
+            <a:avLst/>
+          </a:prstGeom>
+          <a:solidFill>
+            <a:srgbClr val="2568B8"/>
+          </a:solidFill>
+          <a:ln>
+            <a:noFill/>
+          </a:ln>
+        </p:spPr>
+        <p:style>
+          <a:lnRef idx="1">
+            <a:schemeClr val="accent1"/>
+          </a:lnRef>
+          <a:fillRef idx="3">
+            <a:schemeClr val="accent1"/>
+          </a:fillRef>
+          <a:effectRef idx="2">
+            <a:schemeClr val="accent1"/>
+          </a:effectRef>
+          <a:fontRef idx="minor">
+            <a:schemeClr val="lt1"/>
+          </a:fontRef>
+        </p:style>
+        <p:txBody>
+          <a:bodyPr rtlCol="0" anchor="ctr"/>
+          <a:lstStyle/>
+          <a:p>
+            <a:pPr algn="ctr"/>
+          </a:p>
+        </p:txBody>
+      </p:sp>
+      <p:sp>
+        <p:nvSpPr>
+          <p:cNvPr id="17" name="TextBox 16"/>
           <p:cNvSpPr txBox="1"/>
           <p:nvPr/>
         </p:nvSpPr>
         <p:spPr>
           <a:xfrm>
-            <a:off x="502920" y="5522976"/>
+            <a:off x="8458200" y="1207008"/>
+            <a:ext cx="3337560" cy="146304"/>
+          </a:xfrm>
+          <a:prstGeom prst="rect">
+            <a:avLst/>
+          </a:prstGeom>
+          <a:noFill/>
+        </p:spPr>
+        <p:txBody>
+          <a:bodyPr wrap="square" lIns="0" rIns="0" tIns="0" bIns="0">
+            <a:noAutofit/>
+          </a:bodyPr>
+          <a:lstStyle/>
+          <a:p>
+            <a:pPr algn="l"/>
+            <a:r>
+              <a:rPr sz="869" b="1" i="0">
+                <a:solidFill>
+                  <a:srgbClr val="111827"/>
+                </a:solidFill>
+                <a:latin typeface="Aptos"/>
+              </a:rPr>
+              <a:t>Radiology (1,230)</a:t>
+            </a:r>
+          </a:p>
+        </p:txBody>
+      </p:sp>
+      <p:sp>
+        <p:nvSpPr>
+          <p:cNvPr id="18" name="Rectangle 17"/>
+          <p:cNvSpPr/>
+          <p:nvPr/>
+        </p:nvSpPr>
+        <p:spPr>
+          <a:xfrm>
+            <a:off x="8275320" y="1453896"/>
+            <a:ext cx="100584" cy="100584"/>
+          </a:xfrm>
+          <a:prstGeom prst="rect">
+            <a:avLst/>
+          </a:prstGeom>
+          <a:solidFill>
+            <a:srgbClr val="C93636"/>
+          </a:solidFill>
+          <a:ln>
+            <a:noFill/>
+          </a:ln>
+        </p:spPr>
+        <p:style>
+          <a:lnRef idx="1">
+            <a:schemeClr val="accent1"/>
+          </a:lnRef>
+          <a:fillRef idx="3">
+            <a:schemeClr val="accent1"/>
+          </a:fillRef>
+          <a:effectRef idx="2">
+            <a:schemeClr val="accent1"/>
+          </a:effectRef>
+          <a:fontRef idx="minor">
+            <a:schemeClr val="lt1"/>
+          </a:fontRef>
+        </p:style>
+        <p:txBody>
+          <a:bodyPr rtlCol="0" anchor="ctr"/>
+          <a:lstStyle/>
+          <a:p>
+            <a:pPr algn="ctr"/>
+          </a:p>
+        </p:txBody>
+      </p:sp>
+      <p:sp>
+        <p:nvSpPr>
+          <p:cNvPr id="19" name="TextBox 18"/>
+          <p:cNvSpPr txBox="1"/>
+          <p:nvPr/>
+        </p:nvSpPr>
+        <p:spPr>
+          <a:xfrm>
+            <a:off x="8458200" y="1421892"/>
+            <a:ext cx="3337560" cy="146304"/>
+          </a:xfrm>
+          <a:prstGeom prst="rect">
+            <a:avLst/>
+          </a:prstGeom>
+          <a:noFill/>
+        </p:spPr>
+        <p:txBody>
+          <a:bodyPr wrap="square" lIns="0" rIns="0" tIns="0" bIns="0">
+            <a:noAutofit/>
+          </a:bodyPr>
+          <a:lstStyle/>
+          <a:p>
+            <a:pPr algn="l"/>
+            <a:r>
+              <a:rPr sz="869" b="0" i="0">
+                <a:solidFill>
+                  <a:srgbClr val="111827"/>
+                </a:solidFill>
+                <a:latin typeface="Aptos"/>
+              </a:rPr>
+              <a:t>Cardiovascular (154)</a:t>
+            </a:r>
+          </a:p>
+        </p:txBody>
+      </p:sp>
+      <p:sp>
+        <p:nvSpPr>
+          <p:cNvPr id="20" name="Rectangle 19"/>
+          <p:cNvSpPr/>
+          <p:nvPr/>
+        </p:nvSpPr>
+        <p:spPr>
+          <a:xfrm>
+            <a:off x="8275320" y="1668780"/>
+            <a:ext cx="100584" cy="100584"/>
+          </a:xfrm>
+          <a:prstGeom prst="rect">
+            <a:avLst/>
+          </a:prstGeom>
+          <a:solidFill>
+            <a:srgbClr val="E97817"/>
+          </a:solidFill>
+          <a:ln>
+            <a:noFill/>
+          </a:ln>
+        </p:spPr>
+        <p:style>
+          <a:lnRef idx="1">
+            <a:schemeClr val="accent1"/>
+          </a:lnRef>
+          <a:fillRef idx="3">
+            <a:schemeClr val="accent1"/>
+          </a:fillRef>
+          <a:effectRef idx="2">
+            <a:schemeClr val="accent1"/>
+          </a:effectRef>
+          <a:fontRef idx="minor">
+            <a:schemeClr val="lt1"/>
+          </a:fontRef>
+        </p:style>
+        <p:txBody>
+          <a:bodyPr rtlCol="0" anchor="ctr"/>
+          <a:lstStyle/>
+          <a:p>
+            <a:pPr algn="ctr"/>
+          </a:p>
+        </p:txBody>
+      </p:sp>
+      <p:sp>
+        <p:nvSpPr>
+          <p:cNvPr id="21" name="TextBox 20"/>
+          <p:cNvSpPr txBox="1"/>
+          <p:nvPr/>
+        </p:nvSpPr>
+        <p:spPr>
+          <a:xfrm>
+            <a:off x="8458200" y="1636776"/>
+            <a:ext cx="3337560" cy="146304"/>
+          </a:xfrm>
+          <a:prstGeom prst="rect">
+            <a:avLst/>
+          </a:prstGeom>
+          <a:noFill/>
+        </p:spPr>
+        <p:txBody>
+          <a:bodyPr wrap="square" lIns="0" rIns="0" tIns="0" bIns="0">
+            <a:noAutofit/>
+          </a:bodyPr>
+          <a:lstStyle/>
+          <a:p>
+            <a:pPr algn="l"/>
+            <a:r>
+              <a:rPr sz="869" b="0" i="0">
+                <a:solidFill>
+                  <a:srgbClr val="111827"/>
+                </a:solidFill>
+                <a:latin typeface="Aptos"/>
+              </a:rPr>
+              <a:t>Neurology (73)</a:t>
+            </a:r>
+          </a:p>
+        </p:txBody>
+      </p:sp>
+      <p:sp>
+        <p:nvSpPr>
+          <p:cNvPr id="22" name="Rectangle 21"/>
+          <p:cNvSpPr/>
+          <p:nvPr/>
+        </p:nvSpPr>
+        <p:spPr>
+          <a:xfrm>
+            <a:off x="8275320" y="1883664"/>
+            <a:ext cx="100584" cy="100584"/>
+          </a:xfrm>
+          <a:prstGeom prst="rect">
+            <a:avLst/>
+          </a:prstGeom>
+          <a:solidFill>
+            <a:srgbClr val="16858C"/>
+          </a:solidFill>
+          <a:ln>
+            <a:noFill/>
+          </a:ln>
+        </p:spPr>
+        <p:style>
+          <a:lnRef idx="1">
+            <a:schemeClr val="accent1"/>
+          </a:lnRef>
+          <a:fillRef idx="3">
+            <a:schemeClr val="accent1"/>
+          </a:fillRef>
+          <a:effectRef idx="2">
+            <a:schemeClr val="accent1"/>
+          </a:effectRef>
+          <a:fontRef idx="minor">
+            <a:schemeClr val="lt1"/>
+          </a:fontRef>
+        </p:style>
+        <p:txBody>
+          <a:bodyPr rtlCol="0" anchor="ctr"/>
+          <a:lstStyle/>
+          <a:p>
+            <a:pPr algn="ctr"/>
+          </a:p>
+        </p:txBody>
+      </p:sp>
+      <p:sp>
+        <p:nvSpPr>
+          <p:cNvPr id="23" name="TextBox 22"/>
+          <p:cNvSpPr txBox="1"/>
+          <p:nvPr/>
+        </p:nvSpPr>
+        <p:spPr>
+          <a:xfrm>
+            <a:off x="8458200" y="1851660"/>
+            <a:ext cx="3337560" cy="146304"/>
+          </a:xfrm>
+          <a:prstGeom prst="rect">
+            <a:avLst/>
+          </a:prstGeom>
+          <a:noFill/>
+        </p:spPr>
+        <p:txBody>
+          <a:bodyPr wrap="square" lIns="0" rIns="0" tIns="0" bIns="0">
+            <a:noAutofit/>
+          </a:bodyPr>
+          <a:lstStyle/>
+          <a:p>
+            <a:pPr algn="l"/>
+            <a:r>
+              <a:rPr sz="869" b="0" i="0">
+                <a:solidFill>
+                  <a:srgbClr val="111827"/>
+                </a:solidFill>
+                <a:latin typeface="Aptos"/>
+              </a:rPr>
+              <a:t>Anesthesiology (30)</a:t>
+            </a:r>
+          </a:p>
+        </p:txBody>
+      </p:sp>
+      <p:sp>
+        <p:nvSpPr>
+          <p:cNvPr id="24" name="Rectangle 23"/>
+          <p:cNvSpPr/>
+          <p:nvPr/>
+        </p:nvSpPr>
+        <p:spPr>
+          <a:xfrm>
+            <a:off x="8275320" y="2098548"/>
+            <a:ext cx="100584" cy="100584"/>
+          </a:xfrm>
+          <a:prstGeom prst="rect">
+            <a:avLst/>
+          </a:prstGeom>
+          <a:solidFill>
+            <a:srgbClr val="AD2458"/>
+          </a:solidFill>
+          <a:ln>
+            <a:noFill/>
+          </a:ln>
+        </p:spPr>
+        <p:style>
+          <a:lnRef idx="1">
+            <a:schemeClr val="accent1"/>
+          </a:lnRef>
+          <a:fillRef idx="3">
+            <a:schemeClr val="accent1"/>
+          </a:fillRef>
+          <a:effectRef idx="2">
+            <a:schemeClr val="accent1"/>
+          </a:effectRef>
+          <a:fontRef idx="minor">
+            <a:schemeClr val="lt1"/>
+          </a:fontRef>
+        </p:style>
+        <p:txBody>
+          <a:bodyPr rtlCol="0" anchor="ctr"/>
+          <a:lstStyle/>
+          <a:p>
+            <a:pPr algn="ctr"/>
+          </a:p>
+        </p:txBody>
+      </p:sp>
+      <p:sp>
+        <p:nvSpPr>
+          <p:cNvPr id="25" name="TextBox 24"/>
+          <p:cNvSpPr txBox="1"/>
+          <p:nvPr/>
+        </p:nvSpPr>
+        <p:spPr>
+          <a:xfrm>
+            <a:off x="8458200" y="2066543"/>
+            <a:ext cx="3337560" cy="146304"/>
+          </a:xfrm>
+          <a:prstGeom prst="rect">
+            <a:avLst/>
+          </a:prstGeom>
+          <a:noFill/>
+        </p:spPr>
+        <p:txBody>
+          <a:bodyPr wrap="square" lIns="0" rIns="0" tIns="0" bIns="0">
+            <a:noAutofit/>
+          </a:bodyPr>
+          <a:lstStyle/>
+          <a:p>
+            <a:pPr algn="l"/>
+            <a:r>
+              <a:rPr sz="869" b="0" i="0">
+                <a:solidFill>
+                  <a:srgbClr val="111827"/>
+                </a:solidFill>
+                <a:latin typeface="Aptos"/>
+              </a:rPr>
+              <a:t>Gastroenterology/Urology (27)</a:t>
+            </a:r>
+          </a:p>
+        </p:txBody>
+      </p:sp>
+      <p:sp>
+        <p:nvSpPr>
+          <p:cNvPr id="26" name="Rectangle 25"/>
+          <p:cNvSpPr/>
+          <p:nvPr/>
+        </p:nvSpPr>
+        <p:spPr>
+          <a:xfrm>
+            <a:off x="8275320" y="2313432"/>
+            <a:ext cx="100584" cy="100584"/>
+          </a:xfrm>
+          <a:prstGeom prst="rect">
+            <a:avLst/>
+          </a:prstGeom>
+          <a:solidFill>
+            <a:srgbClr val="F3A62A"/>
+          </a:solidFill>
+          <a:ln>
+            <a:noFill/>
+          </a:ln>
+        </p:spPr>
+        <p:style>
+          <a:lnRef idx="1">
+            <a:schemeClr val="accent1"/>
+          </a:lnRef>
+          <a:fillRef idx="3">
+            <a:schemeClr val="accent1"/>
+          </a:fillRef>
+          <a:effectRef idx="2">
+            <a:schemeClr val="accent1"/>
+          </a:effectRef>
+          <a:fontRef idx="minor">
+            <a:schemeClr val="lt1"/>
+          </a:fontRef>
+        </p:style>
+        <p:txBody>
+          <a:bodyPr rtlCol="0" anchor="ctr"/>
+          <a:lstStyle/>
+          <a:p>
+            <a:pPr algn="ctr"/>
+          </a:p>
+        </p:txBody>
+      </p:sp>
+      <p:sp>
+        <p:nvSpPr>
+          <p:cNvPr id="27" name="TextBox 26"/>
+          <p:cNvSpPr txBox="1"/>
+          <p:nvPr/>
+        </p:nvSpPr>
+        <p:spPr>
+          <a:xfrm>
+            <a:off x="8458200" y="2281428"/>
+            <a:ext cx="3337560" cy="146304"/>
+          </a:xfrm>
+          <a:prstGeom prst="rect">
+            <a:avLst/>
+          </a:prstGeom>
+          <a:noFill/>
+        </p:spPr>
+        <p:txBody>
+          <a:bodyPr wrap="square" lIns="0" rIns="0" tIns="0" bIns="0">
+            <a:noAutofit/>
+          </a:bodyPr>
+          <a:lstStyle/>
+          <a:p>
+            <a:pPr algn="l"/>
+            <a:r>
+              <a:rPr sz="869" b="0" i="0">
+                <a:solidFill>
+                  <a:srgbClr val="111827"/>
+                </a:solidFill>
+                <a:latin typeface="Aptos"/>
+              </a:rPr>
+              <a:t>Hematology (22)</a:t>
+            </a:r>
+          </a:p>
+        </p:txBody>
+      </p:sp>
+      <p:sp>
+        <p:nvSpPr>
+          <p:cNvPr id="28" name="Rectangle 27"/>
+          <p:cNvSpPr/>
+          <p:nvPr/>
+        </p:nvSpPr>
+        <p:spPr>
+          <a:xfrm>
+            <a:off x="8275320" y="2528316"/>
+            <a:ext cx="100584" cy="100584"/>
+          </a:xfrm>
+          <a:prstGeom prst="rect">
+            <a:avLst/>
+          </a:prstGeom>
+          <a:solidFill>
+            <a:srgbClr val="3E8B45"/>
+          </a:solidFill>
+          <a:ln>
+            <a:noFill/>
+          </a:ln>
+        </p:spPr>
+        <p:style>
+          <a:lnRef idx="1">
+            <a:schemeClr val="accent1"/>
+          </a:lnRef>
+          <a:fillRef idx="3">
+            <a:schemeClr val="accent1"/>
+          </a:fillRef>
+          <a:effectRef idx="2">
+            <a:schemeClr val="accent1"/>
+          </a:effectRef>
+          <a:fontRef idx="minor">
+            <a:schemeClr val="lt1"/>
+          </a:fontRef>
+        </p:style>
+        <p:txBody>
+          <a:bodyPr rtlCol="0" anchor="ctr"/>
+          <a:lstStyle/>
+          <a:p>
+            <a:pPr algn="ctr"/>
+          </a:p>
+        </p:txBody>
+      </p:sp>
+      <p:sp>
+        <p:nvSpPr>
+          <p:cNvPr id="29" name="TextBox 28"/>
+          <p:cNvSpPr txBox="1"/>
+          <p:nvPr/>
+        </p:nvSpPr>
+        <p:spPr>
+          <a:xfrm>
+            <a:off x="8458200" y="2496312"/>
+            <a:ext cx="3337560" cy="146304"/>
+          </a:xfrm>
+          <a:prstGeom prst="rect">
+            <a:avLst/>
+          </a:prstGeom>
+          <a:noFill/>
+        </p:spPr>
+        <p:txBody>
+          <a:bodyPr wrap="square" lIns="0" rIns="0" tIns="0" bIns="0">
+            <a:noAutofit/>
+          </a:bodyPr>
+          <a:lstStyle/>
+          <a:p>
+            <a:pPr algn="l"/>
+            <a:r>
+              <a:rPr sz="869" b="0" i="0">
+                <a:solidFill>
+                  <a:srgbClr val="111827"/>
+                </a:solidFill>
+                <a:latin typeface="Aptos"/>
+              </a:rPr>
+              <a:t>Ophthalmic (10)</a:t>
+            </a:r>
+          </a:p>
+        </p:txBody>
+      </p:sp>
+      <p:sp>
+        <p:nvSpPr>
+          <p:cNvPr id="30" name="Rectangle 29"/>
+          <p:cNvSpPr/>
+          <p:nvPr/>
+        </p:nvSpPr>
+        <p:spPr>
+          <a:xfrm>
+            <a:off x="8275320" y="2743200"/>
+            <a:ext cx="100584" cy="100584"/>
+          </a:xfrm>
+          <a:prstGeom prst="rect">
+            <a:avLst/>
+          </a:prstGeom>
+          <a:solidFill>
+            <a:srgbClr val="6A2CA0"/>
+          </a:solidFill>
+          <a:ln>
+            <a:noFill/>
+          </a:ln>
+        </p:spPr>
+        <p:style>
+          <a:lnRef idx="1">
+            <a:schemeClr val="accent1"/>
+          </a:lnRef>
+          <a:fillRef idx="3">
+            <a:schemeClr val="accent1"/>
+          </a:fillRef>
+          <a:effectRef idx="2">
+            <a:schemeClr val="accent1"/>
+          </a:effectRef>
+          <a:fontRef idx="minor">
+            <a:schemeClr val="lt1"/>
+          </a:fontRef>
+        </p:style>
+        <p:txBody>
+          <a:bodyPr rtlCol="0" anchor="ctr"/>
+          <a:lstStyle/>
+          <a:p>
+            <a:pPr algn="ctr"/>
+          </a:p>
+        </p:txBody>
+      </p:sp>
+      <p:sp>
+        <p:nvSpPr>
+          <p:cNvPr id="31" name="TextBox 30"/>
+          <p:cNvSpPr txBox="1"/>
+          <p:nvPr/>
+        </p:nvSpPr>
+        <p:spPr>
+          <a:xfrm>
+            <a:off x="8458200" y="2711196"/>
+            <a:ext cx="3337560" cy="146304"/>
+          </a:xfrm>
+          <a:prstGeom prst="rect">
+            <a:avLst/>
+          </a:prstGeom>
+          <a:noFill/>
+        </p:spPr>
+        <p:txBody>
+          <a:bodyPr wrap="square" lIns="0" rIns="0" tIns="0" bIns="0">
+            <a:noAutofit/>
+          </a:bodyPr>
+          <a:lstStyle/>
+          <a:p>
+            <a:pPr algn="l"/>
+            <a:r>
+              <a:rPr sz="869" b="0" i="0">
+                <a:solidFill>
+                  <a:srgbClr val="111827"/>
+                </a:solidFill>
+                <a:latin typeface="Aptos"/>
+              </a:rPr>
+              <a:t>Pathology (10)</a:t>
+            </a:r>
+          </a:p>
+        </p:txBody>
+      </p:sp>
+      <p:sp>
+        <p:nvSpPr>
+          <p:cNvPr id="32" name="Rectangle 31"/>
+          <p:cNvSpPr/>
+          <p:nvPr/>
+        </p:nvSpPr>
+        <p:spPr>
+          <a:xfrm>
+            <a:off x="8275320" y="2958084"/>
+            <a:ext cx="100584" cy="100584"/>
+          </a:xfrm>
+          <a:prstGeom prst="rect">
+            <a:avLst/>
+          </a:prstGeom>
+          <a:solidFill>
+            <a:srgbClr val="4B2CA3"/>
+          </a:solidFill>
+          <a:ln>
+            <a:noFill/>
+          </a:ln>
+        </p:spPr>
+        <p:style>
+          <a:lnRef idx="1">
+            <a:schemeClr val="accent1"/>
+          </a:lnRef>
+          <a:fillRef idx="3">
+            <a:schemeClr val="accent1"/>
+          </a:fillRef>
+          <a:effectRef idx="2">
+            <a:schemeClr val="accent1"/>
+          </a:effectRef>
+          <a:fontRef idx="minor">
+            <a:schemeClr val="lt1"/>
+          </a:fontRef>
+        </p:style>
+        <p:txBody>
+          <a:bodyPr rtlCol="0" anchor="ctr"/>
+          <a:lstStyle/>
+          <a:p>
+            <a:pPr algn="ctr"/>
+          </a:p>
+        </p:txBody>
+      </p:sp>
+      <p:sp>
+        <p:nvSpPr>
+          <p:cNvPr id="33" name="TextBox 32"/>
+          <p:cNvSpPr txBox="1"/>
+          <p:nvPr/>
+        </p:nvSpPr>
+        <p:spPr>
+          <a:xfrm>
+            <a:off x="8458200" y="2926080"/>
+            <a:ext cx="3337560" cy="146304"/>
+          </a:xfrm>
+          <a:prstGeom prst="rect">
+            <a:avLst/>
+          </a:prstGeom>
+          <a:noFill/>
+        </p:spPr>
+        <p:txBody>
+          <a:bodyPr wrap="square" lIns="0" rIns="0" tIns="0" bIns="0">
+            <a:noAutofit/>
+          </a:bodyPr>
+          <a:lstStyle/>
+          <a:p>
+            <a:pPr algn="l"/>
+            <a:r>
+              <a:rPr sz="869" b="0" i="0">
+                <a:solidFill>
+                  <a:srgbClr val="111827"/>
+                </a:solidFill>
+                <a:latin typeface="Aptos"/>
+              </a:rPr>
+              <a:t>General and Plastic Surgery (9)</a:t>
+            </a:r>
+          </a:p>
+        </p:txBody>
+      </p:sp>
+      <p:sp>
+        <p:nvSpPr>
+          <p:cNvPr id="34" name="Rectangle 33"/>
+          <p:cNvSpPr/>
+          <p:nvPr/>
+        </p:nvSpPr>
+        <p:spPr>
+          <a:xfrm>
+            <a:off x="8275320" y="3172968"/>
+            <a:ext cx="100584" cy="100584"/>
+          </a:xfrm>
+          <a:prstGeom prst="rect">
+            <a:avLst/>
+          </a:prstGeom>
+          <a:solidFill>
+            <a:srgbClr val="14725E"/>
+          </a:solidFill>
+          <a:ln>
+            <a:noFill/>
+          </a:ln>
+        </p:spPr>
+        <p:style>
+          <a:lnRef idx="1">
+            <a:schemeClr val="accent1"/>
+          </a:lnRef>
+          <a:fillRef idx="3">
+            <a:schemeClr val="accent1"/>
+          </a:fillRef>
+          <a:effectRef idx="2">
+            <a:schemeClr val="accent1"/>
+          </a:effectRef>
+          <a:fontRef idx="minor">
+            <a:schemeClr val="lt1"/>
+          </a:fontRef>
+        </p:style>
+        <p:txBody>
+          <a:bodyPr rtlCol="0" anchor="ctr"/>
+          <a:lstStyle/>
+          <a:p>
+            <a:pPr algn="ctr"/>
+          </a:p>
+        </p:txBody>
+      </p:sp>
+      <p:sp>
+        <p:nvSpPr>
+          <p:cNvPr id="35" name="TextBox 34"/>
+          <p:cNvSpPr txBox="1"/>
+          <p:nvPr/>
+        </p:nvSpPr>
+        <p:spPr>
+          <a:xfrm>
+            <a:off x="8458200" y="3140963"/>
+            <a:ext cx="3337560" cy="146304"/>
+          </a:xfrm>
+          <a:prstGeom prst="rect">
+            <a:avLst/>
+          </a:prstGeom>
+          <a:noFill/>
+        </p:spPr>
+        <p:txBody>
+          <a:bodyPr wrap="square" lIns="0" rIns="0" tIns="0" bIns="0">
+            <a:noAutofit/>
+          </a:bodyPr>
+          <a:lstStyle/>
+          <a:p>
+            <a:pPr algn="l"/>
+            <a:r>
+              <a:rPr sz="869" b="0" i="0">
+                <a:solidFill>
+                  <a:srgbClr val="111827"/>
+                </a:solidFill>
+                <a:latin typeface="Aptos"/>
+              </a:rPr>
+              <a:t>Other (49)</a:t>
+            </a:r>
+          </a:p>
+        </p:txBody>
+      </p:sp>
+      <p:sp>
+        <p:nvSpPr>
+          <p:cNvPr id="36" name="TextBox 35"/>
+          <p:cNvSpPr txBox="1"/>
+          <p:nvPr/>
+        </p:nvSpPr>
+        <p:spPr>
+          <a:xfrm>
+            <a:off x="502920" y="5468112"/>
             <a:ext cx="11109960" cy="164592"/>
           </a:xfrm>
           <a:prstGeom prst="rect">
@@ -5662,14 +6481,14 @@
           <a:noFill/>
         </p:spPr>
         <p:txBody>
-          <a:bodyPr wrap="none" lIns="0" rIns="0" tIns="0" bIns="0">
-            <a:spAutoFit/>
+          <a:bodyPr wrap="square" lIns="0" rIns="0" tIns="0" bIns="0">
+            <a:noAutofit/>
           </a:bodyPr>
           <a:lstStyle/>
           <a:p>
             <a:pPr algn="l"/>
             <a:r>
-              <a:rPr sz="750" b="0" i="0">
+              <a:rPr sz="740" b="0" i="0">
                 <a:solidFill>
                   <a:srgbClr val="64748B"/>
                 </a:solidFill>
@@ -5682,14 +6501,59 @@
       </p:sp>
       <p:sp>
         <p:nvSpPr>
-          <p:cNvPr id="16" name="TextBox 15"/>
+          <p:cNvPr id="37" name="Rounded Rectangle 36"/>
+          <p:cNvSpPr/>
+          <p:nvPr/>
+        </p:nvSpPr>
+        <p:spPr>
+          <a:xfrm>
+            <a:off x="502920" y="5650992"/>
+            <a:ext cx="11173968" cy="804672"/>
+          </a:xfrm>
+          <a:prstGeom prst="roundRect">
+            <a:avLst/>
+          </a:prstGeom>
+          <a:solidFill>
+            <a:srgbClr val="FFF8CC"/>
+          </a:solidFill>
+          <a:ln w="12700">
+            <a:solidFill>
+              <a:srgbClr val="C7A400"/>
+            </a:solidFill>
+          </a:ln>
+        </p:spPr>
+        <p:style>
+          <a:lnRef idx="1">
+            <a:schemeClr val="accent1"/>
+          </a:lnRef>
+          <a:fillRef idx="3">
+            <a:schemeClr val="accent1"/>
+          </a:fillRef>
+          <a:effectRef idx="2">
+            <a:schemeClr val="accent1"/>
+          </a:effectRef>
+          <a:fontRef idx="minor">
+            <a:schemeClr val="lt1"/>
+          </a:fontRef>
+        </p:style>
+        <p:txBody>
+          <a:bodyPr rtlCol="0" anchor="ctr"/>
+          <a:lstStyle/>
+          <a:p>
+            <a:pPr algn="ctr"/>
+          </a:p>
+        </p:txBody>
+      </p:sp>
+      <p:sp>
+        <p:nvSpPr>
+          <p:cNvPr id="38" name="TextBox 37"/>
           <p:cNvSpPr txBox="1"/>
           <p:nvPr/>
         </p:nvSpPr>
         <p:spPr>
           <a:xfrm>
-            <a:off x="502920" y="5779008"/>
-            <a:ext cx="11155680" cy="502920"/>
+            <a:off x="685800" y="5760720"/>
+            <a:ext cx="2697480" cy="201168"/>
           </a:xfrm>
           <a:prstGeom prst="rect">
             <a:avLst/>
@@ -5697,34 +6561,34 @@
           <a:noFill/>
         </p:spPr>
         <p:txBody>
-          <a:bodyPr wrap="none" lIns="0" rIns="0" tIns="0" bIns="0">
-            <a:spAutoFit/>
+          <a:bodyPr wrap="square" lIns="0" rIns="0" tIns="0" bIns="0">
+            <a:noAutofit/>
           </a:bodyPr>
           <a:lstStyle/>
           <a:p>
             <a:pPr algn="l"/>
             <a:r>
-              <a:rPr sz="650" b="0" i="0">
+              <a:rPr sz="1019" b="1" i="0">
                 <a:solidFill>
-                  <a:srgbClr val="334155"/>
+                  <a:srgbClr val="10233F"/>
                 </a:solidFill>
                 <a:latin typeface="Aptos"/>
               </a:rPr>
-              <a:t>Li S, Andriole K, Chang P, Grimm L, Heilbrun M, Krupinski E, Klontzas M, Amiruddin R, Kadom N, Doo F. AI2Practice: FDA AI-Enabled Medical Device List visualization. AI2Practice. https://um-ihc-ca2i.github.io/ai2practice/tracker.html. Source data: U.S. FDA AI-Enabled Medical Devices List. Visualization adapted by AI2Practice for educational use; not an FDA product or endorsement.</a:t>
-            </a:r>
-          </a:p>
-        </p:txBody>
-      </p:sp>
-      <p:sp>
-        <p:nvSpPr>
-          <p:cNvPr id="17" name="TextBox 16"/>
+              <a:t>Find this useful? Please cite us.</a:t>
+            </a:r>
+          </a:p>
+        </p:txBody>
+      </p:sp>
+      <p:sp>
+        <p:nvSpPr>
+          <p:cNvPr id="39" name="TextBox 38"/>
           <p:cNvSpPr txBox="1"/>
           <p:nvPr/>
         </p:nvSpPr>
         <p:spPr>
           <a:xfrm>
-            <a:off x="502920" y="6345936"/>
-            <a:ext cx="11155680" cy="164592"/>
+            <a:off x="3310128" y="5724144"/>
+            <a:ext cx="8183879" cy="393192"/>
           </a:xfrm>
           <a:prstGeom prst="rect">
             <a:avLst/>
@@ -5732,14 +6596,49 @@
           <a:noFill/>
         </p:spPr>
         <p:txBody>
-          <a:bodyPr wrap="none" lIns="0" rIns="0" tIns="0" bIns="0">
-            <a:spAutoFit/>
+          <a:bodyPr wrap="square" lIns="0" rIns="0" tIns="0" bIns="0">
+            <a:noAutofit/>
           </a:bodyPr>
           <a:lstStyle/>
           <a:p>
             <a:pPr algn="l"/>
             <a:r>
-              <a:rPr sz="650" b="0" i="1">
+              <a:rPr sz="800" b="0" i="0">
+                <a:solidFill>
+                  <a:srgbClr val="1F2937"/>
+                </a:solidFill>
+                <a:latin typeface="Aptos"/>
+              </a:rPr>
+              <a:t>Li S, Andriole K, Chang P, Grimm L, Heilbrun M, Krupinski E, Klontzas M, Amiruddin R, Kadom N, Doo FX. AI2Practice: FDA AI-Enabled Medical Device List visualization. AI2Practice. https://um-ihc-ca2i.github.io/ai2practice/tracker.html. Source data: U.S. FDA AI-Enabled Medical Devices List. Visualization adapted by AI2Practice for educational use; not an FDA product or endorsement.</a:t>
+            </a:r>
+          </a:p>
+        </p:txBody>
+      </p:sp>
+      <p:sp>
+        <p:nvSpPr>
+          <p:cNvPr id="40" name="TextBox 39"/>
+          <p:cNvSpPr txBox="1"/>
+          <p:nvPr/>
+        </p:nvSpPr>
+        <p:spPr>
+          <a:xfrm>
+            <a:off x="3310128" y="6172200"/>
+            <a:ext cx="8183879" cy="155448"/>
+          </a:xfrm>
+          <a:prstGeom prst="rect">
+            <a:avLst/>
+          </a:prstGeom>
+          <a:noFill/>
+        </p:spPr>
+        <p:txBody>
+          <a:bodyPr wrap="square" lIns="0" rIns="0" tIns="0" bIns="0">
+            <a:noAutofit/>
+          </a:bodyPr>
+          <a:lstStyle/>
+          <a:p>
+            <a:pPr algn="l"/>
+            <a:r>
+              <a:rPr sz="690" b="0" i="1">
                 <a:solidFill>
                   <a:srgbClr val="64748B"/>
                 </a:solidFill>

</xml_diff>